<commit_message>
fix: Fix wrong data on slides
</commit_message>
<xml_diff>
--- a/presentation/apresentacao.pptx
+++ b/presentation/apresentacao.pptx
@@ -5,11 +5,11 @@
     <p:sldMasterId id="2147483648" r:id="rId1"/>
   </p:sldMasterIdLst>
   <p:sldIdLst>
-    <p:sldId id="256" r:id="rId7"/>
-    <p:sldId id="257" r:id="rId8"/>
-    <p:sldId id="258" r:id="rId9"/>
+    <p:sldId id="256" r:id="rId2"/>
+    <p:sldId id="257" r:id="rId3"/>
+    <p:sldId id="258" r:id="rId4"/>
   </p:sldIdLst>
-  <p:sldSz cx="12192000" cy="6858000" type="screen4x3"/>
+  <p:sldSz cx="12192000" cy="6858000"/>
   <p:notesSz cx="6858000" cy="9144000"/>
   <p:defaultTextStyle>
     <a:defPPr>
@@ -106,7 +106,106 @@
       </a:defRPr>
     </a:lvl9pPr>
   </p:defaultTextStyle>
+  <p:extLst>
+    <p:ext uri="{EFAFB233-063F-42B5-8137-9DF3F51BA10A}">
+      <p15:sldGuideLst xmlns:p15="http://schemas.microsoft.com/office/powerpoint/2012/main">
+        <p15:guide id="1" orient="horz" pos="2160">
+          <p15:clr>
+            <a:srgbClr val="A4A3A4"/>
+          </p15:clr>
+        </p15:guide>
+        <p15:guide id="2" pos="2880">
+          <p15:clr>
+            <a:srgbClr val="A4A3A4"/>
+          </p15:clr>
+        </p15:guide>
+      </p15:sldGuideLst>
+    </p:ext>
+  </p:extLst>
 </p:presentation>
+</file>
+
+<file path=ppt/changesInfos/changesInfo1.xml><?xml version="1.0" encoding="utf-8"?>
+<pc:chgInfo xmlns:a="http://schemas.openxmlformats.org/drawingml/2006/main" xmlns:r="http://schemas.openxmlformats.org/officeDocument/2006/relationships" xmlns:ac="http://schemas.microsoft.com/office/drawing/2013/main/command" xmlns:pc="http://schemas.microsoft.com/office/powerpoint/2013/main/command">
+  <pc:docChgLst>
+    <pc:chgData name="Allana Rodrigues Abrego" userId="b03a7f8f-0934-4184-80c0-2ca250c2463d" providerId="ADAL" clId="{00F1A537-929B-41ED-95EF-FB367AAA976A}"/>
+    <pc:docChg chg="undo custSel modSld">
+      <pc:chgData name="Allana Rodrigues Abrego" userId="b03a7f8f-0934-4184-80c0-2ca250c2463d" providerId="ADAL" clId="{00F1A537-929B-41ED-95EF-FB367AAA976A}" dt="2026-09-07T23:31:21.555" v="20" actId="1076"/>
+      <pc:docMkLst>
+        <pc:docMk/>
+      </pc:docMkLst>
+      <pc:sldChg chg="modSp mod">
+        <pc:chgData name="Allana Rodrigues Abrego" userId="b03a7f8f-0934-4184-80c0-2ca250c2463d" providerId="ADAL" clId="{00F1A537-929B-41ED-95EF-FB367AAA976A}" dt="2026-09-07T23:27:14.998" v="1" actId="20577"/>
+        <pc:sldMkLst>
+          <pc:docMk/>
+          <pc:sldMk cId="0" sldId="256"/>
+        </pc:sldMkLst>
+        <pc:spChg chg="mod">
+          <ac:chgData name="Allana Rodrigues Abrego" userId="b03a7f8f-0934-4184-80c0-2ca250c2463d" providerId="ADAL" clId="{00F1A537-929B-41ED-95EF-FB367AAA976A}" dt="2026-09-07T23:27:14.998" v="1" actId="20577"/>
+          <ac:spMkLst>
+            <pc:docMk/>
+            <pc:sldMk cId="0" sldId="256"/>
+            <ac:spMk id="8" creationId="{00000000-0000-0000-0000-000000000000}"/>
+          </ac:spMkLst>
+        </pc:spChg>
+      </pc:sldChg>
+      <pc:sldChg chg="modSp mod">
+        <pc:chgData name="Allana Rodrigues Abrego" userId="b03a7f8f-0934-4184-80c0-2ca250c2463d" providerId="ADAL" clId="{00F1A537-929B-41ED-95EF-FB367AAA976A}" dt="2026-09-07T23:31:21.555" v="20" actId="1076"/>
+        <pc:sldMkLst>
+          <pc:docMk/>
+          <pc:sldMk cId="0" sldId="257"/>
+        </pc:sldMkLst>
+        <pc:spChg chg="mod">
+          <ac:chgData name="Allana Rodrigues Abrego" userId="b03a7f8f-0934-4184-80c0-2ca250c2463d" providerId="ADAL" clId="{00F1A537-929B-41ED-95EF-FB367AAA976A}" dt="2026-09-07T23:31:03.053" v="18" actId="1076"/>
+          <ac:spMkLst>
+            <pc:docMk/>
+            <pc:sldMk cId="0" sldId="257"/>
+            <ac:spMk id="13" creationId="{00000000-0000-0000-0000-000000000000}"/>
+          </ac:spMkLst>
+        </pc:spChg>
+        <pc:spChg chg="mod">
+          <ac:chgData name="Allana Rodrigues Abrego" userId="b03a7f8f-0934-4184-80c0-2ca250c2463d" providerId="ADAL" clId="{00F1A537-929B-41ED-95EF-FB367AAA976A}" dt="2026-09-07T23:31:14.096" v="19" actId="1076"/>
+          <ac:spMkLst>
+            <pc:docMk/>
+            <pc:sldMk cId="0" sldId="257"/>
+            <ac:spMk id="14" creationId="{00000000-0000-0000-0000-000000000000}"/>
+          </ac:spMkLst>
+        </pc:spChg>
+        <pc:picChg chg="mod">
+          <ac:chgData name="Allana Rodrigues Abrego" userId="b03a7f8f-0934-4184-80c0-2ca250c2463d" providerId="ADAL" clId="{00F1A537-929B-41ED-95EF-FB367AAA976A}" dt="2026-09-07T23:31:21.555" v="20" actId="1076"/>
+          <ac:picMkLst>
+            <pc:docMk/>
+            <pc:sldMk cId="0" sldId="257"/>
+            <ac:picMk id="15" creationId="{00000000-0000-0000-0000-000000000000}"/>
+          </ac:picMkLst>
+        </pc:picChg>
+      </pc:sldChg>
+      <pc:sldChg chg="modSp mod">
+        <pc:chgData name="Allana Rodrigues Abrego" userId="b03a7f8f-0934-4184-80c0-2ca250c2463d" providerId="ADAL" clId="{00F1A537-929B-41ED-95EF-FB367AAA976A}" dt="2026-09-07T23:29:11.044" v="9" actId="1076"/>
+        <pc:sldMkLst>
+          <pc:docMk/>
+          <pc:sldMk cId="0" sldId="258"/>
+        </pc:sldMkLst>
+        <pc:spChg chg="mod">
+          <ac:chgData name="Allana Rodrigues Abrego" userId="b03a7f8f-0934-4184-80c0-2ca250c2463d" providerId="ADAL" clId="{00F1A537-929B-41ED-95EF-FB367AAA976A}" dt="2026-09-07T23:27:56.468" v="5" actId="1076"/>
+          <ac:spMkLst>
+            <pc:docMk/>
+            <pc:sldMk cId="0" sldId="258"/>
+            <ac:spMk id="2" creationId="{00000000-0000-0000-0000-000000000000}"/>
+          </ac:spMkLst>
+        </pc:spChg>
+        <pc:spChg chg="mod">
+          <ac:chgData name="Allana Rodrigues Abrego" userId="b03a7f8f-0934-4184-80c0-2ca250c2463d" providerId="ADAL" clId="{00F1A537-929B-41ED-95EF-FB367AAA976A}" dt="2026-09-07T23:29:11.044" v="9" actId="1076"/>
+          <ac:spMkLst>
+            <pc:docMk/>
+            <pc:sldMk cId="0" sldId="258"/>
+            <ac:spMk id="8" creationId="{00000000-0000-0000-0000-000000000000}"/>
+          </ac:spMkLst>
+        </pc:spChg>
+      </pc:sldChg>
+    </pc:docChg>
+  </pc:docChgLst>
+</pc:chgInfo>
 </file>
 
 <file path=ppt/slideLayouts/slideLayout1.xml><?xml version="1.0" encoding="utf-8"?>
@@ -147,10 +246,9 @@
           <a:lstStyle/>
           <a:p>
             <a:r>
-              <a:rPr lang="en-US" smtClean="0"/>
+              <a:rPr lang="en-US"/>
               <a:t>Click to edit Master title style</a:t>
             </a:r>
-            <a:endParaRPr lang="en-US"/>
           </a:p>
         </p:txBody>
       </p:sp>
@@ -266,10 +364,9 @@
           </a:lstStyle>
           <a:p>
             <a:r>
-              <a:rPr lang="en-US" smtClean="0"/>
+              <a:rPr lang="en-US"/>
               <a:t>Click to edit Master subtitle style</a:t>
             </a:r>
-            <a:endParaRPr lang="en-US"/>
           </a:p>
         </p:txBody>
       </p:sp>
@@ -290,7 +387,7 @@
           <a:p>
             <a:fld id="{5BCAD085-E8A6-8845-BD4E-CB4CCA059FC4}" type="datetimeFigureOut">
               <a:rPr lang="en-US" smtClean="0"/>
-              <a:t>1/27/13</a:t>
+              <a:t>9/7/2026</a:t>
             </a:fld>
             <a:endParaRPr lang="en-US"/>
           </a:p>
@@ -332,7 +429,7 @@
           <a:p>
             <a:fld id="{C1FF6DA9-008F-8B48-92A6-B652298478BF}" type="slidenum">
               <a:rPr lang="en-US" smtClean="0"/>
-              <a:t>‹#›</a:t>
+              <a:t>‹nº›</a:t>
             </a:fld>
             <a:endParaRPr lang="en-US"/>
           </a:p>
@@ -384,10 +481,9 @@
           <a:lstStyle/>
           <a:p>
             <a:r>
-              <a:rPr lang="en-US" smtClean="0"/>
+              <a:rPr lang="en-US"/>
               <a:t>Click to edit Master title style</a:t>
             </a:r>
-            <a:endParaRPr lang="en-US"/>
           </a:p>
         </p:txBody>
       </p:sp>
@@ -408,38 +504,37 @@
           <a:p>
             <a:pPr lvl="0"/>
             <a:r>
-              <a:rPr lang="en-US" smtClean="0"/>
+              <a:rPr lang="en-US"/>
               <a:t>Click to edit Master text styles</a:t>
             </a:r>
           </a:p>
           <a:p>
             <a:pPr lvl="1"/>
             <a:r>
-              <a:rPr lang="en-US" smtClean="0"/>
+              <a:rPr lang="en-US"/>
               <a:t>Second level</a:t>
             </a:r>
           </a:p>
           <a:p>
             <a:pPr lvl="2"/>
             <a:r>
-              <a:rPr lang="en-US" smtClean="0"/>
+              <a:rPr lang="en-US"/>
               <a:t>Third level</a:t>
             </a:r>
           </a:p>
           <a:p>
             <a:pPr lvl="3"/>
             <a:r>
-              <a:rPr lang="en-US" smtClean="0"/>
+              <a:rPr lang="en-US"/>
               <a:t>Fourth level</a:t>
             </a:r>
           </a:p>
           <a:p>
             <a:pPr lvl="4"/>
             <a:r>
-              <a:rPr lang="en-US" smtClean="0"/>
+              <a:rPr lang="en-US"/>
               <a:t>Fifth level</a:t>
             </a:r>
-            <a:endParaRPr lang="en-US"/>
           </a:p>
         </p:txBody>
       </p:sp>
@@ -460,7 +555,7 @@
           <a:p>
             <a:fld id="{5BCAD085-E8A6-8845-BD4E-CB4CCA059FC4}" type="datetimeFigureOut">
               <a:rPr lang="en-US" smtClean="0"/>
-              <a:t>1/27/13</a:t>
+              <a:t>9/7/2026</a:t>
             </a:fld>
             <a:endParaRPr lang="en-US"/>
           </a:p>
@@ -502,7 +597,7 @@
           <a:p>
             <a:fld id="{C1FF6DA9-008F-8B48-92A6-B652298478BF}" type="slidenum">
               <a:rPr lang="en-US" smtClean="0"/>
-              <a:t>‹#›</a:t>
+              <a:t>‹nº›</a:t>
             </a:fld>
             <a:endParaRPr lang="en-US"/>
           </a:p>
@@ -559,10 +654,9 @@
           <a:lstStyle/>
           <a:p>
             <a:r>
-              <a:rPr lang="en-US" smtClean="0"/>
+              <a:rPr lang="en-US"/>
               <a:t>Click to edit Master title style</a:t>
             </a:r>
-            <a:endParaRPr lang="en-US"/>
           </a:p>
         </p:txBody>
       </p:sp>
@@ -588,38 +682,37 @@
           <a:p>
             <a:pPr lvl="0"/>
             <a:r>
-              <a:rPr lang="en-US" smtClean="0"/>
+              <a:rPr lang="en-US"/>
               <a:t>Click to edit Master text styles</a:t>
             </a:r>
           </a:p>
           <a:p>
             <a:pPr lvl="1"/>
             <a:r>
-              <a:rPr lang="en-US" smtClean="0"/>
+              <a:rPr lang="en-US"/>
               <a:t>Second level</a:t>
             </a:r>
           </a:p>
           <a:p>
             <a:pPr lvl="2"/>
             <a:r>
-              <a:rPr lang="en-US" smtClean="0"/>
+              <a:rPr lang="en-US"/>
               <a:t>Third level</a:t>
             </a:r>
           </a:p>
           <a:p>
             <a:pPr lvl="3"/>
             <a:r>
-              <a:rPr lang="en-US" smtClean="0"/>
+              <a:rPr lang="en-US"/>
               <a:t>Fourth level</a:t>
             </a:r>
           </a:p>
           <a:p>
             <a:pPr lvl="4"/>
             <a:r>
-              <a:rPr lang="en-US" smtClean="0"/>
+              <a:rPr lang="en-US"/>
               <a:t>Fifth level</a:t>
             </a:r>
-            <a:endParaRPr lang="en-US"/>
           </a:p>
         </p:txBody>
       </p:sp>
@@ -640,7 +733,7 @@
           <a:p>
             <a:fld id="{5BCAD085-E8A6-8845-BD4E-CB4CCA059FC4}" type="datetimeFigureOut">
               <a:rPr lang="en-US" smtClean="0"/>
-              <a:t>1/27/13</a:t>
+              <a:t>9/7/2026</a:t>
             </a:fld>
             <a:endParaRPr lang="en-US"/>
           </a:p>
@@ -682,7 +775,7 @@
           <a:p>
             <a:fld id="{C1FF6DA9-008F-8B48-92A6-B652298478BF}" type="slidenum">
               <a:rPr lang="en-US" smtClean="0"/>
-              <a:t>‹#›</a:t>
+              <a:t>‹nº›</a:t>
             </a:fld>
             <a:endParaRPr lang="en-US"/>
           </a:p>
@@ -734,10 +827,9 @@
           <a:lstStyle/>
           <a:p>
             <a:r>
-              <a:rPr lang="en-US" smtClean="0"/>
+              <a:rPr lang="en-US"/>
               <a:t>Click to edit Master title style</a:t>
             </a:r>
-            <a:endParaRPr lang="en-US"/>
           </a:p>
         </p:txBody>
       </p:sp>
@@ -758,38 +850,37 @@
           <a:p>
             <a:pPr lvl="0"/>
             <a:r>
-              <a:rPr lang="en-US" smtClean="0"/>
+              <a:rPr lang="en-US"/>
               <a:t>Click to edit Master text styles</a:t>
             </a:r>
           </a:p>
           <a:p>
             <a:pPr lvl="1"/>
             <a:r>
-              <a:rPr lang="en-US" smtClean="0"/>
+              <a:rPr lang="en-US"/>
               <a:t>Second level</a:t>
             </a:r>
           </a:p>
           <a:p>
             <a:pPr lvl="2"/>
             <a:r>
-              <a:rPr lang="en-US" smtClean="0"/>
+              <a:rPr lang="en-US"/>
               <a:t>Third level</a:t>
             </a:r>
           </a:p>
           <a:p>
             <a:pPr lvl="3"/>
             <a:r>
-              <a:rPr lang="en-US" smtClean="0"/>
+              <a:rPr lang="en-US"/>
               <a:t>Fourth level</a:t>
             </a:r>
           </a:p>
           <a:p>
             <a:pPr lvl="4"/>
             <a:r>
-              <a:rPr lang="en-US" smtClean="0"/>
+              <a:rPr lang="en-US"/>
               <a:t>Fifth level</a:t>
             </a:r>
-            <a:endParaRPr lang="en-US"/>
           </a:p>
         </p:txBody>
       </p:sp>
@@ -810,7 +901,7 @@
           <a:p>
             <a:fld id="{5BCAD085-E8A6-8845-BD4E-CB4CCA059FC4}" type="datetimeFigureOut">
               <a:rPr lang="en-US" smtClean="0"/>
-              <a:t>1/27/13</a:t>
+              <a:t>9/7/2026</a:t>
             </a:fld>
             <a:endParaRPr lang="en-US"/>
           </a:p>
@@ -852,7 +943,7 @@
           <a:p>
             <a:fld id="{C1FF6DA9-008F-8B48-92A6-B652298478BF}" type="slidenum">
               <a:rPr lang="en-US" smtClean="0"/>
-              <a:t>‹#›</a:t>
+              <a:t>‹nº›</a:t>
             </a:fld>
             <a:endParaRPr lang="en-US"/>
           </a:p>
@@ -913,10 +1004,9 @@
           </a:lstStyle>
           <a:p>
             <a:r>
-              <a:rPr lang="en-US" smtClean="0"/>
+              <a:rPr lang="en-US"/>
               <a:t>Click to edit Master title style</a:t>
             </a:r>
-            <a:endParaRPr lang="en-US"/>
           </a:p>
         </p:txBody>
       </p:sp>
@@ -1033,7 +1123,7 @@
           <a:p>
             <a:pPr lvl="0"/>
             <a:r>
-              <a:rPr lang="en-US" smtClean="0"/>
+              <a:rPr lang="en-US"/>
               <a:t>Click to edit Master text styles</a:t>
             </a:r>
           </a:p>
@@ -1056,7 +1146,7 @@
           <a:p>
             <a:fld id="{5BCAD085-E8A6-8845-BD4E-CB4CCA059FC4}" type="datetimeFigureOut">
               <a:rPr lang="en-US" smtClean="0"/>
-              <a:t>1/27/13</a:t>
+              <a:t>9/7/2026</a:t>
             </a:fld>
             <a:endParaRPr lang="en-US"/>
           </a:p>
@@ -1098,7 +1188,7 @@
           <a:p>
             <a:fld id="{C1FF6DA9-008F-8B48-92A6-B652298478BF}" type="slidenum">
               <a:rPr lang="en-US" smtClean="0"/>
-              <a:t>‹#›</a:t>
+              <a:t>‹nº›</a:t>
             </a:fld>
             <a:endParaRPr lang="en-US"/>
           </a:p>
@@ -1150,10 +1240,9 @@
           <a:lstStyle/>
           <a:p>
             <a:r>
-              <a:rPr lang="en-US" smtClean="0"/>
+              <a:rPr lang="en-US"/>
               <a:t>Click to edit Master title style</a:t>
             </a:r>
-            <a:endParaRPr lang="en-US"/>
           </a:p>
         </p:txBody>
       </p:sp>
@@ -1207,38 +1296,37 @@
           <a:p>
             <a:pPr lvl="0"/>
             <a:r>
-              <a:rPr lang="en-US" smtClean="0"/>
+              <a:rPr lang="en-US"/>
               <a:t>Click to edit Master text styles</a:t>
             </a:r>
           </a:p>
           <a:p>
             <a:pPr lvl="1"/>
             <a:r>
-              <a:rPr lang="en-US" smtClean="0"/>
+              <a:rPr lang="en-US"/>
               <a:t>Second level</a:t>
             </a:r>
           </a:p>
           <a:p>
             <a:pPr lvl="2"/>
             <a:r>
-              <a:rPr lang="en-US" smtClean="0"/>
+              <a:rPr lang="en-US"/>
               <a:t>Third level</a:t>
             </a:r>
           </a:p>
           <a:p>
             <a:pPr lvl="3"/>
             <a:r>
-              <a:rPr lang="en-US" smtClean="0"/>
+              <a:rPr lang="en-US"/>
               <a:t>Fourth level</a:t>
             </a:r>
           </a:p>
           <a:p>
             <a:pPr lvl="4"/>
             <a:r>
-              <a:rPr lang="en-US" smtClean="0"/>
+              <a:rPr lang="en-US"/>
               <a:t>Fifth level</a:t>
             </a:r>
-            <a:endParaRPr lang="en-US"/>
           </a:p>
         </p:txBody>
       </p:sp>
@@ -1292,38 +1380,37 @@
           <a:p>
             <a:pPr lvl="0"/>
             <a:r>
-              <a:rPr lang="en-US" smtClean="0"/>
+              <a:rPr lang="en-US"/>
               <a:t>Click to edit Master text styles</a:t>
             </a:r>
           </a:p>
           <a:p>
             <a:pPr lvl="1"/>
             <a:r>
-              <a:rPr lang="en-US" smtClean="0"/>
+              <a:rPr lang="en-US"/>
               <a:t>Second level</a:t>
             </a:r>
           </a:p>
           <a:p>
             <a:pPr lvl="2"/>
             <a:r>
-              <a:rPr lang="en-US" smtClean="0"/>
+              <a:rPr lang="en-US"/>
               <a:t>Third level</a:t>
             </a:r>
           </a:p>
           <a:p>
             <a:pPr lvl="3"/>
             <a:r>
-              <a:rPr lang="en-US" smtClean="0"/>
+              <a:rPr lang="en-US"/>
               <a:t>Fourth level</a:t>
             </a:r>
           </a:p>
           <a:p>
             <a:pPr lvl="4"/>
             <a:r>
-              <a:rPr lang="en-US" smtClean="0"/>
+              <a:rPr lang="en-US"/>
               <a:t>Fifth level</a:t>
             </a:r>
-            <a:endParaRPr lang="en-US"/>
           </a:p>
         </p:txBody>
       </p:sp>
@@ -1344,7 +1431,7 @@
           <a:p>
             <a:fld id="{5BCAD085-E8A6-8845-BD4E-CB4CCA059FC4}" type="datetimeFigureOut">
               <a:rPr lang="en-US" smtClean="0"/>
-              <a:t>1/27/13</a:t>
+              <a:t>9/7/2026</a:t>
             </a:fld>
             <a:endParaRPr lang="en-US"/>
           </a:p>
@@ -1386,7 +1473,7 @@
           <a:p>
             <a:fld id="{C1FF6DA9-008F-8B48-92A6-B652298478BF}" type="slidenum">
               <a:rPr lang="en-US" smtClean="0"/>
-              <a:t>‹#›</a:t>
+              <a:t>‹nº›</a:t>
             </a:fld>
             <a:endParaRPr lang="en-US"/>
           </a:p>
@@ -1442,10 +1529,9 @@
           </a:lstStyle>
           <a:p>
             <a:r>
-              <a:rPr lang="en-US" smtClean="0"/>
+              <a:rPr lang="en-US"/>
               <a:t>Click to edit Master title style</a:t>
             </a:r>
-            <a:endParaRPr lang="en-US"/>
           </a:p>
         </p:txBody>
       </p:sp>
@@ -1508,7 +1594,7 @@
           <a:p>
             <a:pPr lvl="0"/>
             <a:r>
-              <a:rPr lang="en-US" smtClean="0"/>
+              <a:rPr lang="en-US"/>
               <a:t>Click to edit Master text styles</a:t>
             </a:r>
           </a:p>
@@ -1564,38 +1650,37 @@
           <a:p>
             <a:pPr lvl="0"/>
             <a:r>
-              <a:rPr lang="en-US" smtClean="0"/>
+              <a:rPr lang="en-US"/>
               <a:t>Click to edit Master text styles</a:t>
             </a:r>
           </a:p>
           <a:p>
             <a:pPr lvl="1"/>
             <a:r>
-              <a:rPr lang="en-US" smtClean="0"/>
+              <a:rPr lang="en-US"/>
               <a:t>Second level</a:t>
             </a:r>
           </a:p>
           <a:p>
             <a:pPr lvl="2"/>
             <a:r>
-              <a:rPr lang="en-US" smtClean="0"/>
+              <a:rPr lang="en-US"/>
               <a:t>Third level</a:t>
             </a:r>
           </a:p>
           <a:p>
             <a:pPr lvl="3"/>
             <a:r>
-              <a:rPr lang="en-US" smtClean="0"/>
+              <a:rPr lang="en-US"/>
               <a:t>Fourth level</a:t>
             </a:r>
           </a:p>
           <a:p>
             <a:pPr lvl="4"/>
             <a:r>
-              <a:rPr lang="en-US" smtClean="0"/>
+              <a:rPr lang="en-US"/>
               <a:t>Fifth level</a:t>
             </a:r>
-            <a:endParaRPr lang="en-US"/>
           </a:p>
         </p:txBody>
       </p:sp>
@@ -1658,7 +1743,7 @@
           <a:p>
             <a:pPr lvl="0"/>
             <a:r>
-              <a:rPr lang="en-US" smtClean="0"/>
+              <a:rPr lang="en-US"/>
               <a:t>Click to edit Master text styles</a:t>
             </a:r>
           </a:p>
@@ -1714,38 +1799,37 @@
           <a:p>
             <a:pPr lvl="0"/>
             <a:r>
-              <a:rPr lang="en-US" smtClean="0"/>
+              <a:rPr lang="en-US"/>
               <a:t>Click to edit Master text styles</a:t>
             </a:r>
           </a:p>
           <a:p>
             <a:pPr lvl="1"/>
             <a:r>
-              <a:rPr lang="en-US" smtClean="0"/>
+              <a:rPr lang="en-US"/>
               <a:t>Second level</a:t>
             </a:r>
           </a:p>
           <a:p>
             <a:pPr lvl="2"/>
             <a:r>
-              <a:rPr lang="en-US" smtClean="0"/>
+              <a:rPr lang="en-US"/>
               <a:t>Third level</a:t>
             </a:r>
           </a:p>
           <a:p>
             <a:pPr lvl="3"/>
             <a:r>
-              <a:rPr lang="en-US" smtClean="0"/>
+              <a:rPr lang="en-US"/>
               <a:t>Fourth level</a:t>
             </a:r>
           </a:p>
           <a:p>
             <a:pPr lvl="4"/>
             <a:r>
-              <a:rPr lang="en-US" smtClean="0"/>
+              <a:rPr lang="en-US"/>
               <a:t>Fifth level</a:t>
             </a:r>
-            <a:endParaRPr lang="en-US"/>
           </a:p>
         </p:txBody>
       </p:sp>
@@ -1766,7 +1850,7 @@
           <a:p>
             <a:fld id="{5BCAD085-E8A6-8845-BD4E-CB4CCA059FC4}" type="datetimeFigureOut">
               <a:rPr lang="en-US" smtClean="0"/>
-              <a:t>1/27/13</a:t>
+              <a:t>9/7/2026</a:t>
             </a:fld>
             <a:endParaRPr lang="en-US"/>
           </a:p>
@@ -1808,7 +1892,7 @@
           <a:p>
             <a:fld id="{C1FF6DA9-008F-8B48-92A6-B652298478BF}" type="slidenum">
               <a:rPr lang="en-US" smtClean="0"/>
-              <a:t>‹#›</a:t>
+              <a:t>‹nº›</a:t>
             </a:fld>
             <a:endParaRPr lang="en-US"/>
           </a:p>
@@ -1860,10 +1944,9 @@
           <a:lstStyle/>
           <a:p>
             <a:r>
-              <a:rPr lang="en-US" smtClean="0"/>
+              <a:rPr lang="en-US"/>
               <a:t>Click to edit Master title style</a:t>
             </a:r>
-            <a:endParaRPr lang="en-US"/>
           </a:p>
         </p:txBody>
       </p:sp>
@@ -1884,7 +1967,7 @@
           <a:p>
             <a:fld id="{5BCAD085-E8A6-8845-BD4E-CB4CCA059FC4}" type="datetimeFigureOut">
               <a:rPr lang="en-US" smtClean="0"/>
-              <a:t>1/27/13</a:t>
+              <a:t>9/7/2026</a:t>
             </a:fld>
             <a:endParaRPr lang="en-US"/>
           </a:p>
@@ -1926,7 +2009,7 @@
           <a:p>
             <a:fld id="{C1FF6DA9-008F-8B48-92A6-B652298478BF}" type="slidenum">
               <a:rPr lang="en-US" smtClean="0"/>
-              <a:t>‹#›</a:t>
+              <a:t>‹nº›</a:t>
             </a:fld>
             <a:endParaRPr lang="en-US"/>
           </a:p>
@@ -1979,7 +2062,7 @@
           <a:p>
             <a:fld id="{5BCAD085-E8A6-8845-BD4E-CB4CCA059FC4}" type="datetimeFigureOut">
               <a:rPr lang="en-US" smtClean="0"/>
-              <a:t>1/27/13</a:t>
+              <a:t>9/7/2026</a:t>
             </a:fld>
             <a:endParaRPr lang="en-US"/>
           </a:p>
@@ -2021,7 +2104,7 @@
           <a:p>
             <a:fld id="{C1FF6DA9-008F-8B48-92A6-B652298478BF}" type="slidenum">
               <a:rPr lang="en-US" smtClean="0"/>
-              <a:t>‹#›</a:t>
+              <a:t>‹nº›</a:t>
             </a:fld>
             <a:endParaRPr lang="en-US"/>
           </a:p>
@@ -2082,10 +2165,9 @@
           </a:lstStyle>
           <a:p>
             <a:r>
-              <a:rPr lang="en-US" smtClean="0"/>
+              <a:rPr lang="en-US"/>
               <a:t>Click to edit Master title style</a:t>
             </a:r>
-            <a:endParaRPr lang="en-US"/>
           </a:p>
         </p:txBody>
       </p:sp>
@@ -2139,38 +2221,37 @@
           <a:p>
             <a:pPr lvl="0"/>
             <a:r>
-              <a:rPr lang="en-US" smtClean="0"/>
+              <a:rPr lang="en-US"/>
               <a:t>Click to edit Master text styles</a:t>
             </a:r>
           </a:p>
           <a:p>
             <a:pPr lvl="1"/>
             <a:r>
-              <a:rPr lang="en-US" smtClean="0"/>
+              <a:rPr lang="en-US"/>
               <a:t>Second level</a:t>
             </a:r>
           </a:p>
           <a:p>
             <a:pPr lvl="2"/>
             <a:r>
-              <a:rPr lang="en-US" smtClean="0"/>
+              <a:rPr lang="en-US"/>
               <a:t>Third level</a:t>
             </a:r>
           </a:p>
           <a:p>
             <a:pPr lvl="3"/>
             <a:r>
-              <a:rPr lang="en-US" smtClean="0"/>
+              <a:rPr lang="en-US"/>
               <a:t>Fourth level</a:t>
             </a:r>
           </a:p>
           <a:p>
             <a:pPr lvl="4"/>
             <a:r>
-              <a:rPr lang="en-US" smtClean="0"/>
+              <a:rPr lang="en-US"/>
               <a:t>Fifth level</a:t>
             </a:r>
-            <a:endParaRPr lang="en-US"/>
           </a:p>
         </p:txBody>
       </p:sp>
@@ -2233,7 +2314,7 @@
           <a:p>
             <a:pPr lvl="0"/>
             <a:r>
-              <a:rPr lang="en-US" smtClean="0"/>
+              <a:rPr lang="en-US"/>
               <a:t>Click to edit Master text styles</a:t>
             </a:r>
           </a:p>
@@ -2256,7 +2337,7 @@
           <a:p>
             <a:fld id="{5BCAD085-E8A6-8845-BD4E-CB4CCA059FC4}" type="datetimeFigureOut">
               <a:rPr lang="en-US" smtClean="0"/>
-              <a:t>1/27/13</a:t>
+              <a:t>9/7/2026</a:t>
             </a:fld>
             <a:endParaRPr lang="en-US"/>
           </a:p>
@@ -2298,7 +2379,7 @@
           <a:p>
             <a:fld id="{C1FF6DA9-008F-8B48-92A6-B652298478BF}" type="slidenum">
               <a:rPr lang="en-US" smtClean="0"/>
-              <a:t>‹#›</a:t>
+              <a:t>‹nº›</a:t>
             </a:fld>
             <a:endParaRPr lang="en-US"/>
           </a:p>
@@ -2359,10 +2440,9 @@
           </a:lstStyle>
           <a:p>
             <a:r>
-              <a:rPr lang="en-US" smtClean="0"/>
+              <a:rPr lang="en-US"/>
               <a:t>Click to edit Master title style</a:t>
             </a:r>
-            <a:endParaRPr lang="en-US"/>
           </a:p>
         </p:txBody>
       </p:sp>
@@ -2486,7 +2566,7 @@
           <a:p>
             <a:pPr lvl="0"/>
             <a:r>
-              <a:rPr lang="en-US" smtClean="0"/>
+              <a:rPr lang="en-US"/>
               <a:t>Click to edit Master text styles</a:t>
             </a:r>
           </a:p>
@@ -2509,7 +2589,7 @@
           <a:p>
             <a:fld id="{5BCAD085-E8A6-8845-BD4E-CB4CCA059FC4}" type="datetimeFigureOut">
               <a:rPr lang="en-US" smtClean="0"/>
-              <a:t>1/27/13</a:t>
+              <a:t>9/7/2026</a:t>
             </a:fld>
             <a:endParaRPr lang="en-US"/>
           </a:p>
@@ -2551,7 +2631,7 @@
           <a:p>
             <a:fld id="{C1FF6DA9-008F-8B48-92A6-B652298478BF}" type="slidenum">
               <a:rPr lang="en-US" smtClean="0"/>
-              <a:t>‹#›</a:t>
+              <a:t>‹nº›</a:t>
             </a:fld>
             <a:endParaRPr lang="en-US"/>
           </a:p>
@@ -2618,10 +2698,9 @@
           <a:lstStyle/>
           <a:p>
             <a:r>
-              <a:rPr lang="en-US" smtClean="0"/>
+              <a:rPr lang="en-US"/>
               <a:t>Click to edit Master title style</a:t>
             </a:r>
-            <a:endParaRPr lang="en-US"/>
           </a:p>
         </p:txBody>
       </p:sp>
@@ -2652,38 +2731,37 @@
           <a:p>
             <a:pPr lvl="0"/>
             <a:r>
-              <a:rPr lang="en-US" smtClean="0"/>
+              <a:rPr lang="en-US"/>
               <a:t>Click to edit Master text styles</a:t>
             </a:r>
           </a:p>
           <a:p>
             <a:pPr lvl="1"/>
             <a:r>
-              <a:rPr lang="en-US" smtClean="0"/>
+              <a:rPr lang="en-US"/>
               <a:t>Second level</a:t>
             </a:r>
           </a:p>
           <a:p>
             <a:pPr lvl="2"/>
             <a:r>
-              <a:rPr lang="en-US" smtClean="0"/>
+              <a:rPr lang="en-US"/>
               <a:t>Third level</a:t>
             </a:r>
           </a:p>
           <a:p>
             <a:pPr lvl="3"/>
             <a:r>
-              <a:rPr lang="en-US" smtClean="0"/>
+              <a:rPr lang="en-US"/>
               <a:t>Fourth level</a:t>
             </a:r>
           </a:p>
           <a:p>
             <a:pPr lvl="4"/>
             <a:r>
-              <a:rPr lang="en-US" smtClean="0"/>
+              <a:rPr lang="en-US"/>
               <a:t>Fifth level</a:t>
             </a:r>
-            <a:endParaRPr lang="en-US"/>
           </a:p>
         </p:txBody>
       </p:sp>
@@ -2722,7 +2800,7 @@
           <a:p>
             <a:fld id="{5BCAD085-E8A6-8845-BD4E-CB4CCA059FC4}" type="datetimeFigureOut">
               <a:rPr lang="en-US" smtClean="0"/>
-              <a:t>1/27/13</a:t>
+              <a:t>9/7/2026</a:t>
             </a:fld>
             <a:endParaRPr lang="en-US"/>
           </a:p>
@@ -2800,7 +2878,7 @@
           <a:p>
             <a:fld id="{C1FF6DA9-008F-8B48-92A6-B652298478BF}" type="slidenum">
               <a:rPr lang="en-US" smtClean="0"/>
-              <a:t>‹#›</a:t>
+              <a:t>‹nº›</a:t>
             </a:fld>
             <a:endParaRPr lang="en-US"/>
           </a:p>
@@ -3081,7 +3159,7 @@
 </file>
 
 <file path=ppt/slides/slide1.xml><?xml version="1.0" encoding="utf-8"?>
-<p:sld xmlns:a="http://schemas.openxmlformats.org/drawingml/2006/main" xmlns:p="http://schemas.openxmlformats.org/presentationml/2006/main" xmlns:r="http://schemas.openxmlformats.org/officeDocument/2006/relationships">
+<p:sld xmlns:a="http://schemas.openxmlformats.org/drawingml/2006/main" xmlns:r="http://schemas.openxmlformats.org/officeDocument/2006/relationships" xmlns:p="http://schemas.openxmlformats.org/presentationml/2006/main">
   <p:cSld>
     <p:spTree>
       <p:nvGrpSpPr>
@@ -3089,7 +3167,14 @@
         <p:cNvGrpSpPr/>
         <p:nvPr/>
       </p:nvGrpSpPr>
-      <p:grpSpPr/>
+      <p:grpSpPr>
+        <a:xfrm>
+          <a:off x="0" y="0"/>
+          <a:ext cx="0" cy="0"/>
+          <a:chOff x="0" y="0"/>
+          <a:chExt cx="0" cy="0"/>
+        </a:xfrm>
+      </p:grpSpPr>
       <p:sp>
         <p:nvSpPr>
           <p:cNvPr id="2" name="Rectangle 1"/>
@@ -3131,6 +3216,7 @@
           <a:lstStyle/>
           <a:p>
             <a:pPr algn="ctr"/>
+            <a:endParaRPr/>
           </a:p>
         </p:txBody>
       </p:sp>
@@ -3178,6 +3264,7 @@
           <a:lstStyle/>
           <a:p>
             <a:pPr algn="ctr"/>
+            <a:endParaRPr/>
           </a:p>
         </p:txBody>
       </p:sp>
@@ -3222,6 +3309,7 @@
           <a:lstStyle/>
           <a:p>
             <a:pPr algn="ctr"/>
+            <a:endParaRPr/>
           </a:p>
         </p:txBody>
       </p:sp>
@@ -3304,7 +3392,8 @@
                 </a:solidFill>
                 <a:latin typeface="Baskerville"/>
               </a:rPr>
-              <a:t>R$ 378 mil por semana</a:t>
+              <a:t>R$ 25 mil por semana
+em contratos que vão atrasar</a:t>
             </a:r>
           </a:p>
           <a:p>
@@ -3316,15 +3405,12 @@
                 <a:spcPts val="0"/>
               </a:spcAft>
             </a:pPr>
-            <a:r>
-              <a:rPr sz="3300" b="0" i="0">
-                <a:solidFill>
-                  <a:srgbClr val="6D8196"/>
-                </a:solidFill>
-                <a:latin typeface="Baskerville"/>
-              </a:rPr>
-              <a:t>em contratos que vão atrasar</a:t>
-            </a:r>
+            <a:endParaRPr sz="3300" b="0" i="0">
+              <a:solidFill>
+                <a:srgbClr val="6D8196"/>
+              </a:solidFill>
+              <a:latin typeface="Baskerville"/>
+            </a:endParaRPr>
           </a:p>
         </p:txBody>
       </p:sp>
@@ -3369,6 +3455,7 @@
           <a:lstStyle/>
           <a:p>
             <a:pPr algn="ctr"/>
+            <a:endParaRPr/>
           </a:p>
         </p:txBody>
       </p:sp>
@@ -3403,13 +3490,366 @@
               </a:spcAft>
             </a:pPr>
             <a:r>
-              <a:rPr sz="1350" b="0" i="0">
-                <a:solidFill>
-                  <a:srgbClr val="3E4C5A"/>
-                </a:solidFill>
-                <a:latin typeface="Avenir Next"/>
-              </a:rPr>
-              <a:t>Prevemos quem não vai pagar a próxima parcela em até 30 dias, sete dias antes do vencimento.</a:t>
+              <a:rPr sz="1350" b="0" i="0" dirty="0" err="1">
+                <a:solidFill>
+                  <a:srgbClr val="3E4C5A"/>
+                </a:solidFill>
+                <a:latin typeface="Avenir Next"/>
+              </a:rPr>
+              <a:t>Prevemos</a:t>
+            </a:r>
+            <a:r>
+              <a:rPr sz="1350" b="0" i="0" dirty="0">
+                <a:solidFill>
+                  <a:srgbClr val="3E4C5A"/>
+                </a:solidFill>
+                <a:latin typeface="Avenir Next"/>
+              </a:rPr>
+              <a:t> quem </a:t>
+            </a:r>
+            <a:r>
+              <a:rPr sz="1350" b="0" i="0" dirty="0" err="1">
+                <a:solidFill>
+                  <a:srgbClr val="3E4C5A"/>
+                </a:solidFill>
+                <a:latin typeface="Avenir Next"/>
+              </a:rPr>
+              <a:t>não</a:t>
+            </a:r>
+            <a:r>
+              <a:rPr sz="1350" b="0" i="0" dirty="0">
+                <a:solidFill>
+                  <a:srgbClr val="3E4C5A"/>
+                </a:solidFill>
+                <a:latin typeface="Avenir Next"/>
+              </a:rPr>
+              <a:t> </a:t>
+            </a:r>
+            <a:r>
+              <a:rPr sz="1350" b="0" i="0" dirty="0" err="1">
+                <a:solidFill>
+                  <a:srgbClr val="3E4C5A"/>
+                </a:solidFill>
+                <a:latin typeface="Avenir Next"/>
+              </a:rPr>
+              <a:t>vai</a:t>
+            </a:r>
+            <a:r>
+              <a:rPr sz="1350" b="0" i="0" dirty="0">
+                <a:solidFill>
+                  <a:srgbClr val="3E4C5A"/>
+                </a:solidFill>
+                <a:latin typeface="Avenir Next"/>
+              </a:rPr>
+              <a:t> </a:t>
+            </a:r>
+            <a:r>
+              <a:rPr sz="1350" b="0" i="0" dirty="0" err="1">
+                <a:solidFill>
+                  <a:srgbClr val="3E4C5A"/>
+                </a:solidFill>
+                <a:latin typeface="Avenir Next"/>
+              </a:rPr>
+              <a:t>pagar</a:t>
+            </a:r>
+            <a:r>
+              <a:rPr sz="1350" b="0" i="0" dirty="0">
+                <a:solidFill>
+                  <a:srgbClr val="3E4C5A"/>
+                </a:solidFill>
+                <a:latin typeface="Avenir Next"/>
+              </a:rPr>
+              <a:t> a </a:t>
+            </a:r>
+            <a:r>
+              <a:rPr sz="1350" b="0" i="0" dirty="0" err="1">
+                <a:solidFill>
+                  <a:srgbClr val="3E4C5A"/>
+                </a:solidFill>
+                <a:latin typeface="Avenir Next"/>
+              </a:rPr>
+              <a:t>próxima</a:t>
+            </a:r>
+            <a:r>
+              <a:rPr sz="1350" b="0" i="0" dirty="0">
+                <a:solidFill>
+                  <a:srgbClr val="3E4C5A"/>
+                </a:solidFill>
+                <a:latin typeface="Avenir Next"/>
+              </a:rPr>
+              <a:t> </a:t>
+            </a:r>
+            <a:r>
+              <a:rPr sz="1350" b="0" i="0" dirty="0" err="1">
+                <a:solidFill>
+                  <a:srgbClr val="3E4C5A"/>
+                </a:solidFill>
+                <a:latin typeface="Avenir Next"/>
+              </a:rPr>
+              <a:t>parcela</a:t>
+            </a:r>
+            <a:r>
+              <a:rPr sz="1350" b="0" i="0" dirty="0">
+                <a:solidFill>
+                  <a:srgbClr val="3E4C5A"/>
+                </a:solidFill>
+                <a:latin typeface="Avenir Next"/>
+              </a:rPr>
+              <a:t> </a:t>
+            </a:r>
+            <a:r>
+              <a:rPr sz="1350" b="0" i="0" dirty="0" err="1">
+                <a:solidFill>
+                  <a:srgbClr val="3E4C5A"/>
+                </a:solidFill>
+                <a:latin typeface="Avenir Next"/>
+              </a:rPr>
+              <a:t>em</a:t>
+            </a:r>
+            <a:r>
+              <a:rPr sz="1350" b="0" i="0" dirty="0">
+                <a:solidFill>
+                  <a:srgbClr val="3E4C5A"/>
+                </a:solidFill>
+                <a:latin typeface="Avenir Next"/>
+              </a:rPr>
+              <a:t> </a:t>
+            </a:r>
+            <a:r>
+              <a:rPr sz="1350" b="0" i="0" dirty="0" err="1">
+                <a:solidFill>
+                  <a:srgbClr val="3E4C5A"/>
+                </a:solidFill>
+                <a:latin typeface="Avenir Next"/>
+              </a:rPr>
+              <a:t>até</a:t>
+            </a:r>
+            <a:r>
+              <a:rPr sz="1350" b="0" i="0" dirty="0">
+                <a:solidFill>
+                  <a:srgbClr val="3E4C5A"/>
+                </a:solidFill>
+                <a:latin typeface="Avenir Next"/>
+              </a:rPr>
+              <a:t> 30 </a:t>
+            </a:r>
+            <a:r>
+              <a:rPr sz="1350" b="0" i="0" dirty="0" err="1">
+                <a:solidFill>
+                  <a:srgbClr val="3E4C5A"/>
+                </a:solidFill>
+                <a:latin typeface="Avenir Next"/>
+              </a:rPr>
+              <a:t>dias</a:t>
+            </a:r>
+            <a:r>
+              <a:rPr sz="1350" b="0" i="0" dirty="0">
+                <a:solidFill>
+                  <a:srgbClr val="3E4C5A"/>
+                </a:solidFill>
+                <a:latin typeface="Avenir Next"/>
+              </a:rPr>
+              <a:t>, </a:t>
+            </a:r>
+            <a:r>
+              <a:rPr sz="1350" b="0" i="0" dirty="0" err="1">
+                <a:solidFill>
+                  <a:srgbClr val="3E4C5A"/>
+                </a:solidFill>
+                <a:latin typeface="Avenir Next"/>
+              </a:rPr>
+              <a:t>sete</a:t>
+            </a:r>
+            <a:r>
+              <a:rPr sz="1350" b="0" i="0" dirty="0">
+                <a:solidFill>
+                  <a:srgbClr val="3E4C5A"/>
+                </a:solidFill>
+                <a:latin typeface="Avenir Next"/>
+              </a:rPr>
+              <a:t> </a:t>
+            </a:r>
+            <a:r>
+              <a:rPr sz="1350" b="0" i="0" dirty="0" err="1">
+                <a:solidFill>
+                  <a:srgbClr val="3E4C5A"/>
+                </a:solidFill>
+                <a:latin typeface="Avenir Next"/>
+              </a:rPr>
+              <a:t>dias</a:t>
+            </a:r>
+            <a:r>
+              <a:rPr sz="1350" b="0" i="0" dirty="0">
+                <a:solidFill>
+                  <a:srgbClr val="3E4C5A"/>
+                </a:solidFill>
+                <a:latin typeface="Avenir Next"/>
+              </a:rPr>
+              <a:t> </a:t>
+            </a:r>
+            <a:r>
+              <a:rPr lang="pt-BR" sz="1350" b="0" i="0" dirty="0">
+                <a:solidFill>
+                  <a:srgbClr val="3E4C5A"/>
+                </a:solidFill>
+                <a:latin typeface="Avenir Next"/>
+              </a:rPr>
+              <a:t>antes do vencimento.
+Cada contrato que chega aos 30 dias custa R$ 1.200. Na média da base (428 dias), cerca de 21 contratos por semana chegam aos 30 dias de atraso.
+Uma correção: o status do cadastro não serve para isso. Em 62 contratos ele discorda do que de fato aconteceu</a:t>
+            </a:r>
+            <a:r>
+              <a:rPr sz="1350" b="0" i="0" dirty="0">
+                <a:solidFill>
+                  <a:srgbClr val="3E4C5A"/>
+                </a:solidFill>
+                <a:latin typeface="Avenir Next"/>
+              </a:rPr>
+              <a:t>, </a:t>
+            </a:r>
+            <a:r>
+              <a:rPr sz="1350" b="0" i="0" dirty="0" err="1">
+                <a:solidFill>
+                  <a:srgbClr val="3E4C5A"/>
+                </a:solidFill>
+                <a:latin typeface="Avenir Next"/>
+              </a:rPr>
+              <a:t>incluindo</a:t>
+            </a:r>
+            <a:r>
+              <a:rPr sz="1350" b="0" i="0" dirty="0">
+                <a:solidFill>
+                  <a:srgbClr val="3E4C5A"/>
+                </a:solidFill>
+                <a:latin typeface="Avenir Next"/>
+              </a:rPr>
+              <a:t> 22 </a:t>
+            </a:r>
+            <a:r>
+              <a:rPr sz="1350" b="0" i="0" dirty="0" err="1">
+                <a:solidFill>
+                  <a:srgbClr val="3E4C5A"/>
+                </a:solidFill>
+                <a:latin typeface="Avenir Next"/>
+              </a:rPr>
+              <a:t>marcados</a:t>
+            </a:r>
+            <a:r>
+              <a:rPr sz="1350" b="0" i="0" dirty="0">
+                <a:solidFill>
+                  <a:srgbClr val="3E4C5A"/>
+                </a:solidFill>
+                <a:latin typeface="Avenir Next"/>
+              </a:rPr>
+              <a:t> </a:t>
+            </a:r>
+            <a:r>
+              <a:rPr sz="1350" b="0" i="0" dirty="0" err="1">
+                <a:solidFill>
+                  <a:srgbClr val="3E4C5A"/>
+                </a:solidFill>
+                <a:latin typeface="Avenir Next"/>
+              </a:rPr>
+              <a:t>como</a:t>
+            </a:r>
+            <a:r>
+              <a:rPr sz="1350" b="0" i="0" dirty="0">
+                <a:solidFill>
+                  <a:srgbClr val="3E4C5A"/>
+                </a:solidFill>
+                <a:latin typeface="Avenir Next"/>
+              </a:rPr>
+              <a:t> </a:t>
+            </a:r>
+            <a:r>
+              <a:rPr sz="1350" b="0" i="0" dirty="0" err="1">
+                <a:solidFill>
+                  <a:srgbClr val="3E4C5A"/>
+                </a:solidFill>
+                <a:latin typeface="Avenir Next"/>
+              </a:rPr>
+              <a:t>quitados</a:t>
+            </a:r>
+            <a:r>
+              <a:rPr sz="1350" b="0" i="0" dirty="0">
+                <a:solidFill>
+                  <a:srgbClr val="3E4C5A"/>
+                </a:solidFill>
+                <a:latin typeface="Avenir Next"/>
+              </a:rPr>
+              <a:t> </a:t>
+            </a:r>
+            <a:r>
+              <a:rPr sz="1350" b="0" i="0" dirty="0" err="1">
+                <a:solidFill>
+                  <a:srgbClr val="3E4C5A"/>
+                </a:solidFill>
+                <a:latin typeface="Avenir Next"/>
+              </a:rPr>
+              <a:t>que</a:t>
+            </a:r>
+            <a:r>
+              <a:rPr sz="1350" b="0" i="0" dirty="0">
+                <a:solidFill>
+                  <a:srgbClr val="3E4C5A"/>
+                </a:solidFill>
+                <a:latin typeface="Avenir Next"/>
+              </a:rPr>
+              <a:t> </a:t>
+            </a:r>
+            <a:r>
+              <a:rPr sz="1350" b="0" i="0" dirty="0" err="1">
+                <a:solidFill>
+                  <a:srgbClr val="3E4C5A"/>
+                </a:solidFill>
+                <a:latin typeface="Avenir Next"/>
+              </a:rPr>
+              <a:t>passaram</a:t>
+            </a:r>
+            <a:r>
+              <a:rPr sz="1350" b="0" i="0" dirty="0">
+                <a:solidFill>
+                  <a:srgbClr val="3E4C5A"/>
+                </a:solidFill>
+                <a:latin typeface="Avenir Next"/>
+              </a:rPr>
+              <a:t> dos 30 </a:t>
+            </a:r>
+            <a:r>
+              <a:rPr sz="1350" b="0" i="0" dirty="0" err="1">
+                <a:solidFill>
+                  <a:srgbClr val="3E4C5A"/>
+                </a:solidFill>
+                <a:latin typeface="Avenir Next"/>
+              </a:rPr>
+              <a:t>dias</a:t>
+            </a:r>
+            <a:r>
+              <a:rPr sz="1350" b="0" i="0" dirty="0">
+                <a:solidFill>
+                  <a:srgbClr val="3E4C5A"/>
+                </a:solidFill>
+                <a:latin typeface="Avenir Next"/>
+              </a:rPr>
+              <a:t> de </a:t>
+            </a:r>
+            <a:r>
+              <a:rPr sz="1350" b="0" i="0" dirty="0" err="1">
+                <a:solidFill>
+                  <a:srgbClr val="3E4C5A"/>
+                </a:solidFill>
+                <a:latin typeface="Avenir Next"/>
+              </a:rPr>
+              <a:t>atraso</a:t>
+            </a:r>
+            <a:r>
+              <a:rPr sz="1350" b="0" i="0" dirty="0">
+                <a:solidFill>
+                  <a:srgbClr val="3E4C5A"/>
+                </a:solidFill>
+                <a:latin typeface="Avenir Next"/>
+              </a:rPr>
+              <a:t>.</a:t>
             </a:r>
           </a:p>
           <a:p>
@@ -3421,15 +3861,12 @@
                 <a:spcPts val="1300"/>
               </a:spcAft>
             </a:pPr>
-            <a:r>
-              <a:rPr sz="1350" b="0" i="0">
-                <a:solidFill>
-                  <a:srgbClr val="3E4C5A"/>
-                </a:solidFill>
-                <a:latin typeface="Avenir Next"/>
-              </a:rPr>
-              <a:t>Cada contrato que chega aos 30 dias custa R$ 1.200. Numa semana típica, 315 contratos chegam lá.</a:t>
-            </a:r>
+            <a:endParaRPr sz="1350" b="0" i="0" dirty="0">
+              <a:solidFill>
+                <a:srgbClr val="3E4C5A"/>
+              </a:solidFill>
+              <a:latin typeface="Avenir Next"/>
+            </a:endParaRPr>
           </a:p>
           <a:p>
             <a:pPr algn="l">
@@ -3440,15 +3877,12 @@
                 <a:spcPts val="1300"/>
               </a:spcAft>
             </a:pPr>
-            <a:r>
-              <a:rPr sz="1350" b="0" i="0">
-                <a:solidFill>
-                  <a:srgbClr val="3E4C5A"/>
-                </a:solidFill>
-                <a:latin typeface="Avenir Next"/>
-              </a:rPr>
-              <a:t>Uma correção: o status do cadastro não serve para isso. Em 62 contratos ele discorda do que de fato aconteceu, incluindo 22 marcados como quitados que passaram dos 30 dias de atraso.</a:t>
-            </a:r>
+            <a:endParaRPr sz="1350" b="0" i="0" dirty="0">
+              <a:solidFill>
+                <a:srgbClr val="3E4C5A"/>
+              </a:solidFill>
+              <a:latin typeface="Avenir Next"/>
+            </a:endParaRPr>
           </a:p>
         </p:txBody>
       </p:sp>
@@ -3493,6 +3927,7 @@
           <a:lstStyle/>
           <a:p>
             <a:pPr algn="ctr"/>
+            <a:endParaRPr/>
           </a:p>
         </p:txBody>
       </p:sp>
@@ -3611,13 +4046,13 @@
               </a:spcAft>
             </a:pPr>
             <a:r>
-              <a:rPr sz="4400" b="0" i="0">
+              <a:rPr sz="4400" b="0" i="0" dirty="0">
                 <a:solidFill>
                   <a:srgbClr val="6D8196"/>
                 </a:solidFill>
                 <a:latin typeface="Baskerville"/>
               </a:rPr>
-              <a:t>R$ 378.000</a:t>
+              <a:t>R$ 25.500</a:t>
             </a:r>
           </a:p>
         </p:txBody>
@@ -3659,7 +4094,7 @@
                 </a:solidFill>
                 <a:latin typeface="Avenir Next"/>
               </a:rPr>
-              <a:t>315 contratos × R$ 1.200</a:t>
+              <a:t>~21 contratos/semana × R$ 1.200</a:t>
             </a:r>
           </a:p>
         </p:txBody>
@@ -3697,7 +4132,7 @@
 </file>
 
 <file path=ppt/slides/slide2.xml><?xml version="1.0" encoding="utf-8"?>
-<p:sld xmlns:a="http://schemas.openxmlformats.org/drawingml/2006/main" xmlns:p="http://schemas.openxmlformats.org/presentationml/2006/main" xmlns:r="http://schemas.openxmlformats.org/officeDocument/2006/relationships">
+<p:sld xmlns:a="http://schemas.openxmlformats.org/drawingml/2006/main" xmlns:r="http://schemas.openxmlformats.org/officeDocument/2006/relationships" xmlns:p="http://schemas.openxmlformats.org/presentationml/2006/main">
   <p:cSld>
     <p:spTree>
       <p:nvGrpSpPr>
@@ -3705,7 +4140,14 @@
         <p:cNvGrpSpPr/>
         <p:nvPr/>
       </p:nvGrpSpPr>
-      <p:grpSpPr/>
+      <p:grpSpPr>
+        <a:xfrm>
+          <a:off x="0" y="0"/>
+          <a:ext cx="0" cy="0"/>
+          <a:chOff x="0" y="0"/>
+          <a:chExt cx="0" cy="0"/>
+        </a:xfrm>
+      </p:grpSpPr>
       <p:sp>
         <p:nvSpPr>
           <p:cNvPr id="2" name="Rectangle 1"/>
@@ -3747,6 +4189,7 @@
           <a:lstStyle/>
           <a:p>
             <a:pPr algn="ctr"/>
+            <a:endParaRPr/>
           </a:p>
         </p:txBody>
       </p:sp>
@@ -3794,6 +4237,7 @@
           <a:lstStyle/>
           <a:p>
             <a:pPr algn="ctr"/>
+            <a:endParaRPr/>
           </a:p>
         </p:txBody>
       </p:sp>
@@ -3838,6 +4282,7 @@
           <a:lstStyle/>
           <a:p>
             <a:pPr algn="ctr"/>
+            <a:endParaRPr/>
           </a:p>
         </p:txBody>
       </p:sp>
@@ -3985,6 +4430,7 @@
           <a:lstStyle/>
           <a:p>
             <a:pPr algn="ctr"/>
+            <a:endParaRPr/>
           </a:p>
         </p:txBody>
       </p:sp>
@@ -4061,13 +4507,211 @@
               </a:spcAft>
             </a:pPr>
             <a:r>
-              <a:rPr sz="1250" b="0" i="0">
-                <a:solidFill>
-                  <a:srgbClr val="3E4C5A"/>
-                </a:solidFill>
-                <a:latin typeface="Avenir Next"/>
-              </a:rPr>
-              <a:t>Bairro e sexo  ·  risco jurídico, e medem renda com o rótulo errado. No lugar: o peso da parcela na renda.</a:t>
+              <a:rPr sz="1250" b="0" i="0" dirty="0">
+                <a:solidFill>
+                  <a:srgbClr val="3E4C5A"/>
+                </a:solidFill>
+                <a:latin typeface="Avenir Next"/>
+              </a:rPr>
+              <a:t>Bairro e </a:t>
+            </a:r>
+            <a:r>
+              <a:rPr sz="1250" b="0" i="0" dirty="0" err="1">
+                <a:solidFill>
+                  <a:srgbClr val="3E4C5A"/>
+                </a:solidFill>
+                <a:latin typeface="Avenir Next"/>
+              </a:rPr>
+              <a:t>sexo</a:t>
+            </a:r>
+            <a:r>
+              <a:rPr sz="1250" b="0" i="0" dirty="0">
+                <a:solidFill>
+                  <a:srgbClr val="3E4C5A"/>
+                </a:solidFill>
+                <a:latin typeface="Avenir Next"/>
+              </a:rPr>
+              <a:t>  ·  </a:t>
+            </a:r>
+            <a:r>
+              <a:rPr sz="1250" b="0" i="0" dirty="0" err="1">
+                <a:solidFill>
+                  <a:srgbClr val="3E4C5A"/>
+                </a:solidFill>
+                <a:latin typeface="Avenir Next"/>
+              </a:rPr>
+              <a:t>risco</a:t>
+            </a:r>
+            <a:r>
+              <a:rPr sz="1250" b="0" i="0" dirty="0">
+                <a:solidFill>
+                  <a:srgbClr val="3E4C5A"/>
+                </a:solidFill>
+                <a:latin typeface="Avenir Next"/>
+              </a:rPr>
+              <a:t> </a:t>
+            </a:r>
+            <a:r>
+              <a:rPr sz="1250" b="0" i="0" dirty="0" err="1">
+                <a:solidFill>
+                  <a:srgbClr val="3E4C5A"/>
+                </a:solidFill>
+                <a:latin typeface="Avenir Next"/>
+              </a:rPr>
+              <a:t>jurídico</a:t>
+            </a:r>
+            <a:r>
+              <a:rPr sz="1250" b="0" i="0" dirty="0">
+                <a:solidFill>
+                  <a:srgbClr val="3E4C5A"/>
+                </a:solidFill>
+                <a:latin typeface="Avenir Next"/>
+              </a:rPr>
+              <a:t>, e </a:t>
+            </a:r>
+            <a:r>
+              <a:rPr sz="1250" b="0" i="0" dirty="0" err="1">
+                <a:solidFill>
+                  <a:srgbClr val="3E4C5A"/>
+                </a:solidFill>
+                <a:latin typeface="Avenir Next"/>
+              </a:rPr>
+              <a:t>medem</a:t>
+            </a:r>
+            <a:r>
+              <a:rPr sz="1250" b="0" i="0" dirty="0">
+                <a:solidFill>
+                  <a:srgbClr val="3E4C5A"/>
+                </a:solidFill>
+                <a:latin typeface="Avenir Next"/>
+              </a:rPr>
+              <a:t> </a:t>
+            </a:r>
+            <a:r>
+              <a:rPr sz="1250" b="0" i="0" dirty="0" err="1">
+                <a:solidFill>
+                  <a:srgbClr val="3E4C5A"/>
+                </a:solidFill>
+                <a:latin typeface="Avenir Next"/>
+              </a:rPr>
+              <a:t>renda</a:t>
+            </a:r>
+            <a:r>
+              <a:rPr sz="1250" b="0" i="0" dirty="0">
+                <a:solidFill>
+                  <a:srgbClr val="3E4C5A"/>
+                </a:solidFill>
+                <a:latin typeface="Avenir Next"/>
+              </a:rPr>
+              <a:t> com o </a:t>
+            </a:r>
+            <a:r>
+              <a:rPr sz="1250" b="0" i="0" dirty="0" err="1">
+                <a:solidFill>
+                  <a:srgbClr val="3E4C5A"/>
+                </a:solidFill>
+                <a:latin typeface="Avenir Next"/>
+              </a:rPr>
+              <a:t>rótulo</a:t>
+            </a:r>
+            <a:r>
+              <a:rPr sz="1250" b="0" i="0" dirty="0">
+                <a:solidFill>
+                  <a:srgbClr val="3E4C5A"/>
+                </a:solidFill>
+                <a:latin typeface="Avenir Next"/>
+              </a:rPr>
+              <a:t> </a:t>
+            </a:r>
+            <a:r>
+              <a:rPr sz="1250" b="0" i="0" dirty="0" err="1">
+                <a:solidFill>
+                  <a:srgbClr val="3E4C5A"/>
+                </a:solidFill>
+                <a:latin typeface="Avenir Next"/>
+              </a:rPr>
+              <a:t>errado</a:t>
+            </a:r>
+            <a:r>
+              <a:rPr sz="1250" b="0" i="0" dirty="0">
+                <a:solidFill>
+                  <a:srgbClr val="3E4C5A"/>
+                </a:solidFill>
+                <a:latin typeface="Avenir Next"/>
+              </a:rPr>
+              <a:t>. No </a:t>
+            </a:r>
+            <a:r>
+              <a:rPr sz="1250" b="0" i="0" dirty="0" err="1">
+                <a:solidFill>
+                  <a:srgbClr val="3E4C5A"/>
+                </a:solidFill>
+                <a:latin typeface="Avenir Next"/>
+              </a:rPr>
+              <a:t>lugar</a:t>
+            </a:r>
+            <a:r>
+              <a:rPr sz="1250" b="0" i="0" dirty="0">
+                <a:solidFill>
+                  <a:srgbClr val="3E4C5A"/>
+                </a:solidFill>
+                <a:latin typeface="Avenir Next"/>
+              </a:rPr>
+              <a:t>: o peso da </a:t>
+            </a:r>
+            <a:r>
+              <a:rPr sz="1250" b="0" i="0" dirty="0" err="1">
+                <a:solidFill>
+                  <a:srgbClr val="3E4C5A"/>
+                </a:solidFill>
+                <a:latin typeface="Avenir Next"/>
+              </a:rPr>
+              <a:t>parcela</a:t>
+            </a:r>
+            <a:r>
+              <a:rPr sz="1250" b="0" i="0" dirty="0">
+                <a:solidFill>
+                  <a:srgbClr val="3E4C5A"/>
+                </a:solidFill>
+                <a:latin typeface="Avenir Next"/>
+              </a:rPr>
+              <a:t> </a:t>
+            </a:r>
+            <a:r>
+              <a:rPr sz="1250" b="0" i="0" dirty="0" err="1">
+                <a:solidFill>
+                  <a:srgbClr val="3E4C5A"/>
+                </a:solidFill>
+                <a:latin typeface="Avenir Next"/>
+              </a:rPr>
+              <a:t>na</a:t>
+            </a:r>
+            <a:r>
+              <a:rPr sz="1250" b="0" i="0" dirty="0">
+                <a:solidFill>
+                  <a:srgbClr val="3E4C5A"/>
+                </a:solidFill>
+                <a:latin typeface="Avenir Next"/>
+              </a:rPr>
+              <a:t> </a:t>
+            </a:r>
+            <a:r>
+              <a:rPr sz="1250" b="0" i="0" dirty="0" err="1">
+                <a:solidFill>
+                  <a:srgbClr val="3E4C5A"/>
+                </a:solidFill>
+                <a:latin typeface="Avenir Next"/>
+              </a:rPr>
+              <a:t>renda</a:t>
+            </a:r>
+            <a:r>
+              <a:rPr sz="1250" b="0" i="0" dirty="0">
+                <a:solidFill>
+                  <a:srgbClr val="3E4C5A"/>
+                </a:solidFill>
+                <a:latin typeface="Avenir Next"/>
+              </a:rPr>
+              <a:t>.</a:t>
             </a:r>
           </a:p>
           <a:p>
@@ -4080,13 +4724,211 @@
               </a:spcAft>
             </a:pPr>
             <a:r>
-              <a:rPr sz="1250" b="0" i="0">
-                <a:solidFill>
-                  <a:srgbClr val="3E4C5A"/>
-                </a:solidFill>
-                <a:latin typeface="Avenir Next"/>
-              </a:rPr>
-              <a:t>Status do contrato  ·  é a foto de hoje, não existia na hora da ligação. No lugar: o histórico de pagamento até aquela data.</a:t>
+              <a:rPr sz="1250" b="0" i="0" dirty="0">
+                <a:solidFill>
+                  <a:srgbClr val="3E4C5A"/>
+                </a:solidFill>
+                <a:latin typeface="Avenir Next"/>
+              </a:rPr>
+              <a:t>Status do </a:t>
+            </a:r>
+            <a:r>
+              <a:rPr sz="1250" b="0" i="0" dirty="0" err="1">
+                <a:solidFill>
+                  <a:srgbClr val="3E4C5A"/>
+                </a:solidFill>
+                <a:latin typeface="Avenir Next"/>
+              </a:rPr>
+              <a:t>contrato</a:t>
+            </a:r>
+            <a:r>
+              <a:rPr sz="1250" b="0" i="0" dirty="0">
+                <a:solidFill>
+                  <a:srgbClr val="3E4C5A"/>
+                </a:solidFill>
+                <a:latin typeface="Avenir Next"/>
+              </a:rPr>
+              <a:t>  ·  é a </a:t>
+            </a:r>
+            <a:r>
+              <a:rPr sz="1250" b="0" i="0" dirty="0" err="1">
+                <a:solidFill>
+                  <a:srgbClr val="3E4C5A"/>
+                </a:solidFill>
+                <a:latin typeface="Avenir Next"/>
+              </a:rPr>
+              <a:t>foto</a:t>
+            </a:r>
+            <a:r>
+              <a:rPr sz="1250" b="0" i="0" dirty="0">
+                <a:solidFill>
+                  <a:srgbClr val="3E4C5A"/>
+                </a:solidFill>
+                <a:latin typeface="Avenir Next"/>
+              </a:rPr>
+              <a:t> de </a:t>
+            </a:r>
+            <a:r>
+              <a:rPr sz="1250" b="0" i="0" dirty="0" err="1">
+                <a:solidFill>
+                  <a:srgbClr val="3E4C5A"/>
+                </a:solidFill>
+                <a:latin typeface="Avenir Next"/>
+              </a:rPr>
+              <a:t>hoje</a:t>
+            </a:r>
+            <a:r>
+              <a:rPr sz="1250" b="0" i="0" dirty="0">
+                <a:solidFill>
+                  <a:srgbClr val="3E4C5A"/>
+                </a:solidFill>
+                <a:latin typeface="Avenir Next"/>
+              </a:rPr>
+              <a:t>, </a:t>
+            </a:r>
+            <a:r>
+              <a:rPr sz="1250" b="0" i="0" dirty="0" err="1">
+                <a:solidFill>
+                  <a:srgbClr val="3E4C5A"/>
+                </a:solidFill>
+                <a:latin typeface="Avenir Next"/>
+              </a:rPr>
+              <a:t>não</a:t>
+            </a:r>
+            <a:r>
+              <a:rPr sz="1250" b="0" i="0" dirty="0">
+                <a:solidFill>
+                  <a:srgbClr val="3E4C5A"/>
+                </a:solidFill>
+                <a:latin typeface="Avenir Next"/>
+              </a:rPr>
+              <a:t> </a:t>
+            </a:r>
+            <a:r>
+              <a:rPr sz="1250" b="0" i="0" dirty="0" err="1">
+                <a:solidFill>
+                  <a:srgbClr val="3E4C5A"/>
+                </a:solidFill>
+                <a:latin typeface="Avenir Next"/>
+              </a:rPr>
+              <a:t>existia</a:t>
+            </a:r>
+            <a:r>
+              <a:rPr sz="1250" b="0" i="0" dirty="0">
+                <a:solidFill>
+                  <a:srgbClr val="3E4C5A"/>
+                </a:solidFill>
+                <a:latin typeface="Avenir Next"/>
+              </a:rPr>
+              <a:t> </a:t>
+            </a:r>
+            <a:r>
+              <a:rPr sz="1250" b="0" i="0" dirty="0" err="1">
+                <a:solidFill>
+                  <a:srgbClr val="3E4C5A"/>
+                </a:solidFill>
+                <a:latin typeface="Avenir Next"/>
+              </a:rPr>
+              <a:t>na</a:t>
+            </a:r>
+            <a:r>
+              <a:rPr sz="1250" b="0" i="0" dirty="0">
+                <a:solidFill>
+                  <a:srgbClr val="3E4C5A"/>
+                </a:solidFill>
+                <a:latin typeface="Avenir Next"/>
+              </a:rPr>
+              <a:t> hora da </a:t>
+            </a:r>
+            <a:r>
+              <a:rPr sz="1250" b="0" i="0" dirty="0" err="1">
+                <a:solidFill>
+                  <a:srgbClr val="3E4C5A"/>
+                </a:solidFill>
+                <a:latin typeface="Avenir Next"/>
+              </a:rPr>
+              <a:t>ligação</a:t>
+            </a:r>
+            <a:r>
+              <a:rPr sz="1250" b="0" i="0" dirty="0">
+                <a:solidFill>
+                  <a:srgbClr val="3E4C5A"/>
+                </a:solidFill>
+                <a:latin typeface="Avenir Next"/>
+              </a:rPr>
+              <a:t>. No </a:t>
+            </a:r>
+            <a:r>
+              <a:rPr sz="1250" b="0" i="0" dirty="0" err="1">
+                <a:solidFill>
+                  <a:srgbClr val="3E4C5A"/>
+                </a:solidFill>
+                <a:latin typeface="Avenir Next"/>
+              </a:rPr>
+              <a:t>lugar</a:t>
+            </a:r>
+            <a:r>
+              <a:rPr sz="1250" b="0" i="0" dirty="0">
+                <a:solidFill>
+                  <a:srgbClr val="3E4C5A"/>
+                </a:solidFill>
+                <a:latin typeface="Avenir Next"/>
+              </a:rPr>
+              <a:t>: o histórico de </a:t>
+            </a:r>
+            <a:r>
+              <a:rPr sz="1250" b="0" i="0" dirty="0" err="1">
+                <a:solidFill>
+                  <a:srgbClr val="3E4C5A"/>
+                </a:solidFill>
+                <a:latin typeface="Avenir Next"/>
+              </a:rPr>
+              <a:t>pagamento</a:t>
+            </a:r>
+            <a:r>
+              <a:rPr sz="1250" b="0" i="0" dirty="0">
+                <a:solidFill>
+                  <a:srgbClr val="3E4C5A"/>
+                </a:solidFill>
+                <a:latin typeface="Avenir Next"/>
+              </a:rPr>
+              <a:t> </a:t>
+            </a:r>
+            <a:r>
+              <a:rPr sz="1250" b="0" i="0" dirty="0" err="1">
+                <a:solidFill>
+                  <a:srgbClr val="3E4C5A"/>
+                </a:solidFill>
+                <a:latin typeface="Avenir Next"/>
+              </a:rPr>
+              <a:t>até</a:t>
+            </a:r>
+            <a:r>
+              <a:rPr sz="1250" b="0" i="0" dirty="0">
+                <a:solidFill>
+                  <a:srgbClr val="3E4C5A"/>
+                </a:solidFill>
+                <a:latin typeface="Avenir Next"/>
+              </a:rPr>
+              <a:t> </a:t>
+            </a:r>
+            <a:r>
+              <a:rPr sz="1250" b="0" i="0" dirty="0" err="1">
+                <a:solidFill>
+                  <a:srgbClr val="3E4C5A"/>
+                </a:solidFill>
+                <a:latin typeface="Avenir Next"/>
+              </a:rPr>
+              <a:t>aquela</a:t>
+            </a:r>
+            <a:r>
+              <a:rPr sz="1250" b="0" i="0" dirty="0">
+                <a:solidFill>
+                  <a:srgbClr val="3E4C5A"/>
+                </a:solidFill>
+                <a:latin typeface="Avenir Next"/>
+              </a:rPr>
+              <a:t> data.</a:t>
             </a:r>
           </a:p>
           <a:p>
@@ -4099,13 +4941,256 @@
               </a:spcAft>
             </a:pPr>
             <a:r>
-              <a:rPr sz="1250" b="0" i="0">
-                <a:solidFill>
-                  <a:srgbClr val="3E4C5A"/>
-                </a:solidFill>
-                <a:latin typeface="Avenir Next"/>
-              </a:rPr>
-              <a:t>Motivos de atraso  ·  o arquivo não tem número de contrato. Peça a extração com a chave e ele vira roteiro de ligação.</a:t>
+              <a:rPr sz="1250" b="0" i="0" dirty="0" err="1">
+                <a:solidFill>
+                  <a:srgbClr val="3E4C5A"/>
+                </a:solidFill>
+                <a:latin typeface="Avenir Next"/>
+              </a:rPr>
+              <a:t>Motivos</a:t>
+            </a:r>
+            <a:r>
+              <a:rPr sz="1250" b="0" i="0" dirty="0">
+                <a:solidFill>
+                  <a:srgbClr val="3E4C5A"/>
+                </a:solidFill>
+                <a:latin typeface="Avenir Next"/>
+              </a:rPr>
+              <a:t> de </a:t>
+            </a:r>
+            <a:r>
+              <a:rPr sz="1250" b="0" i="0" dirty="0" err="1">
+                <a:solidFill>
+                  <a:srgbClr val="3E4C5A"/>
+                </a:solidFill>
+                <a:latin typeface="Avenir Next"/>
+              </a:rPr>
+              <a:t>atraso</a:t>
+            </a:r>
+            <a:r>
+              <a:rPr sz="1250" b="0" i="0" dirty="0">
+                <a:solidFill>
+                  <a:srgbClr val="3E4C5A"/>
+                </a:solidFill>
+                <a:latin typeface="Avenir Next"/>
+              </a:rPr>
+              <a:t>  ·  o </a:t>
+            </a:r>
+            <a:r>
+              <a:rPr sz="1250" b="0" i="0" dirty="0" err="1">
+                <a:solidFill>
+                  <a:srgbClr val="3E4C5A"/>
+                </a:solidFill>
+                <a:latin typeface="Avenir Next"/>
+              </a:rPr>
+              <a:t>arquivo</a:t>
+            </a:r>
+            <a:r>
+              <a:rPr sz="1250" b="0" i="0" dirty="0">
+                <a:solidFill>
+                  <a:srgbClr val="3E4C5A"/>
+                </a:solidFill>
+                <a:latin typeface="Avenir Next"/>
+              </a:rPr>
+              <a:t> </a:t>
+            </a:r>
+            <a:r>
+              <a:rPr sz="1250" b="0" i="0" dirty="0" err="1">
+                <a:solidFill>
+                  <a:srgbClr val="3E4C5A"/>
+                </a:solidFill>
+                <a:latin typeface="Avenir Next"/>
+              </a:rPr>
+              <a:t>não</a:t>
+            </a:r>
+            <a:r>
+              <a:rPr sz="1250" b="0" i="0" dirty="0">
+                <a:solidFill>
+                  <a:srgbClr val="3E4C5A"/>
+                </a:solidFill>
+                <a:latin typeface="Avenir Next"/>
+              </a:rPr>
+              <a:t> </a:t>
+            </a:r>
+            <a:r>
+              <a:rPr sz="1250" b="0" i="0" dirty="0" err="1">
+                <a:solidFill>
+                  <a:srgbClr val="3E4C5A"/>
+                </a:solidFill>
+                <a:latin typeface="Avenir Next"/>
+              </a:rPr>
+              <a:t>tem</a:t>
+            </a:r>
+            <a:r>
+              <a:rPr sz="1250" b="0" i="0" dirty="0">
+                <a:solidFill>
+                  <a:srgbClr val="3E4C5A"/>
+                </a:solidFill>
+                <a:latin typeface="Avenir Next"/>
+              </a:rPr>
+              <a:t> </a:t>
+            </a:r>
+            <a:r>
+              <a:rPr sz="1250" b="0" i="0" dirty="0" err="1">
+                <a:solidFill>
+                  <a:srgbClr val="3E4C5A"/>
+                </a:solidFill>
+                <a:latin typeface="Avenir Next"/>
+              </a:rPr>
+              <a:t>número</a:t>
+            </a:r>
+            <a:r>
+              <a:rPr sz="1250" b="0" i="0" dirty="0">
+                <a:solidFill>
+                  <a:srgbClr val="3E4C5A"/>
+                </a:solidFill>
+                <a:latin typeface="Avenir Next"/>
+              </a:rPr>
+              <a:t> de </a:t>
+            </a:r>
+            <a:r>
+              <a:rPr sz="1250" b="0" i="0" dirty="0" err="1">
+                <a:solidFill>
+                  <a:srgbClr val="3E4C5A"/>
+                </a:solidFill>
+                <a:latin typeface="Avenir Next"/>
+              </a:rPr>
+              <a:t>contrato</a:t>
+            </a:r>
+            <a:r>
+              <a:rPr sz="1250" b="0" i="0" dirty="0">
+                <a:solidFill>
+                  <a:srgbClr val="3E4C5A"/>
+                </a:solidFill>
+                <a:latin typeface="Avenir Next"/>
+              </a:rPr>
+              <a:t>. </a:t>
+            </a:r>
+            <a:r>
+              <a:rPr sz="1250" b="0" i="0" dirty="0" err="1">
+                <a:solidFill>
+                  <a:srgbClr val="3E4C5A"/>
+                </a:solidFill>
+                <a:latin typeface="Avenir Next"/>
+              </a:rPr>
+              <a:t>Peça</a:t>
+            </a:r>
+            <a:r>
+              <a:rPr sz="1250" b="0" i="0" dirty="0">
+                <a:solidFill>
+                  <a:srgbClr val="3E4C5A"/>
+                </a:solidFill>
+                <a:latin typeface="Avenir Next"/>
+              </a:rPr>
+              <a:t> a </a:t>
+            </a:r>
+            <a:r>
+              <a:rPr sz="1250" b="0" i="0" dirty="0" err="1">
+                <a:solidFill>
+                  <a:srgbClr val="3E4C5A"/>
+                </a:solidFill>
+                <a:latin typeface="Avenir Next"/>
+              </a:rPr>
+              <a:t>extração</a:t>
+            </a:r>
+            <a:r>
+              <a:rPr sz="1250" b="0" i="0" dirty="0">
+                <a:solidFill>
+                  <a:srgbClr val="3E4C5A"/>
+                </a:solidFill>
+                <a:latin typeface="Avenir Next"/>
+              </a:rPr>
+              <a:t> com a </a:t>
+            </a:r>
+            <a:r>
+              <a:rPr sz="1250" b="0" i="0" dirty="0" err="1">
+                <a:solidFill>
+                  <a:srgbClr val="3E4C5A"/>
+                </a:solidFill>
+                <a:latin typeface="Avenir Next"/>
+              </a:rPr>
+              <a:t>chave</a:t>
+            </a:r>
+            <a:r>
+              <a:rPr sz="1250" b="0" i="0" dirty="0">
+                <a:solidFill>
+                  <a:srgbClr val="3E4C5A"/>
+                </a:solidFill>
+                <a:latin typeface="Avenir Next"/>
+              </a:rPr>
+              <a:t> e </a:t>
+            </a:r>
+            <a:r>
+              <a:rPr sz="1250" b="0" i="0" dirty="0" err="1">
+                <a:solidFill>
+                  <a:srgbClr val="3E4C5A"/>
+                </a:solidFill>
+                <a:latin typeface="Avenir Next"/>
+              </a:rPr>
+              <a:t>ele</a:t>
+            </a:r>
+            <a:r>
+              <a:rPr sz="1250" b="0" i="0" dirty="0">
+                <a:solidFill>
+                  <a:srgbClr val="3E4C5A"/>
+                </a:solidFill>
+                <a:latin typeface="Avenir Next"/>
+              </a:rPr>
+              <a:t> </a:t>
+            </a:r>
+            <a:r>
+              <a:rPr sz="1250" b="0" i="0" dirty="0" err="1">
+                <a:solidFill>
+                  <a:srgbClr val="3E4C5A"/>
+                </a:solidFill>
+                <a:latin typeface="Avenir Next"/>
+              </a:rPr>
+              <a:t>vira</a:t>
+            </a:r>
+            <a:r>
+              <a:rPr sz="1250" b="0" i="0" dirty="0">
+                <a:solidFill>
+                  <a:srgbClr val="3E4C5A"/>
+                </a:solidFill>
+                <a:latin typeface="Avenir Next"/>
+              </a:rPr>
+              <a:t> </a:t>
+            </a:r>
+            <a:r>
+              <a:rPr sz="1250" b="0" i="0" dirty="0" err="1">
+                <a:solidFill>
+                  <a:srgbClr val="3E4C5A"/>
+                </a:solidFill>
+                <a:latin typeface="Avenir Next"/>
+              </a:rPr>
+              <a:t>roteiro</a:t>
+            </a:r>
+            <a:r>
+              <a:rPr sz="1250" b="0" i="0" dirty="0">
+                <a:solidFill>
+                  <a:srgbClr val="3E4C5A"/>
+                </a:solidFill>
+                <a:latin typeface="Avenir Next"/>
+              </a:rPr>
+              <a:t> de </a:t>
+            </a:r>
+            <a:r>
+              <a:rPr sz="1250" b="0" i="0" dirty="0" err="1">
+                <a:solidFill>
+                  <a:srgbClr val="3E4C5A"/>
+                </a:solidFill>
+                <a:latin typeface="Avenir Next"/>
+              </a:rPr>
+              <a:t>ligação</a:t>
+            </a:r>
+            <a:r>
+              <a:rPr sz="1250" b="0" i="0" dirty="0">
+                <a:solidFill>
+                  <a:srgbClr val="3E4C5A"/>
+                </a:solidFill>
+                <a:latin typeface="Avenir Next"/>
+              </a:rPr>
+              <a:t>.</a:t>
             </a:r>
           </a:p>
           <a:p>
@@ -4118,13 +5203,175 @@
               </a:spcAft>
             </a:pPr>
             <a:r>
-              <a:rPr sz="1250" b="0" i="0">
-                <a:solidFill>
-                  <a:srgbClr val="3E4C5A"/>
-                </a:solidFill>
-                <a:latin typeface="Avenir Next"/>
-              </a:rPr>
-              <a:t>O score de bureau foi usado e paga o próprio custo: é o segundo sinal mais forte da lista.</a:t>
+              <a:rPr sz="1250" b="0" i="0" dirty="0">
+                <a:solidFill>
+                  <a:srgbClr val="3E4C5A"/>
+                </a:solidFill>
+                <a:latin typeface="Avenir Next"/>
+              </a:rPr>
+              <a:t>O score de bureau </a:t>
+            </a:r>
+            <a:r>
+              <a:rPr sz="1250" b="0" i="0" dirty="0" err="1">
+                <a:solidFill>
+                  <a:srgbClr val="3E4C5A"/>
+                </a:solidFill>
+                <a:latin typeface="Avenir Next"/>
+              </a:rPr>
+              <a:t>foi</a:t>
+            </a:r>
+            <a:r>
+              <a:rPr sz="1250" b="0" i="0" dirty="0">
+                <a:solidFill>
+                  <a:srgbClr val="3E4C5A"/>
+                </a:solidFill>
+                <a:latin typeface="Avenir Next"/>
+              </a:rPr>
+              <a:t> </a:t>
+            </a:r>
+            <a:r>
+              <a:rPr sz="1250" b="0" i="0" dirty="0" err="1">
+                <a:solidFill>
+                  <a:srgbClr val="3E4C5A"/>
+                </a:solidFill>
+                <a:latin typeface="Avenir Next"/>
+              </a:rPr>
+              <a:t>usado</a:t>
+            </a:r>
+            <a:r>
+              <a:rPr sz="1250" b="0" i="0" dirty="0">
+                <a:solidFill>
+                  <a:srgbClr val="3E4C5A"/>
+                </a:solidFill>
+                <a:latin typeface="Avenir Next"/>
+              </a:rPr>
+              <a:t> e </a:t>
+            </a:r>
+            <a:r>
+              <a:rPr sz="1250" b="0" i="0" dirty="0" err="1">
+                <a:solidFill>
+                  <a:srgbClr val="3E4C5A"/>
+                </a:solidFill>
+                <a:latin typeface="Avenir Next"/>
+              </a:rPr>
+              <a:t>paga</a:t>
+            </a:r>
+            <a:r>
+              <a:rPr sz="1250" b="0" i="0" dirty="0">
+                <a:solidFill>
+                  <a:srgbClr val="3E4C5A"/>
+                </a:solidFill>
+                <a:latin typeface="Avenir Next"/>
+              </a:rPr>
+              <a:t> o </a:t>
+            </a:r>
+            <a:r>
+              <a:rPr sz="1250" b="0" i="0" dirty="0" err="1">
+                <a:solidFill>
+                  <a:srgbClr val="3E4C5A"/>
+                </a:solidFill>
+                <a:latin typeface="Avenir Next"/>
+              </a:rPr>
+              <a:t>próprio</a:t>
+            </a:r>
+            <a:r>
+              <a:rPr sz="1250" b="0" i="0" dirty="0">
+                <a:solidFill>
+                  <a:srgbClr val="3E4C5A"/>
+                </a:solidFill>
+                <a:latin typeface="Avenir Next"/>
+              </a:rPr>
+              <a:t> </a:t>
+            </a:r>
+            <a:r>
+              <a:rPr sz="1250" b="0" i="0" dirty="0" err="1">
+                <a:solidFill>
+                  <a:srgbClr val="3E4C5A"/>
+                </a:solidFill>
+                <a:latin typeface="Avenir Next"/>
+              </a:rPr>
+              <a:t>custo</a:t>
+            </a:r>
+            <a:r>
+              <a:rPr sz="1250" b="0" i="0" dirty="0">
+                <a:solidFill>
+                  <a:srgbClr val="3E4C5A"/>
+                </a:solidFill>
+                <a:latin typeface="Avenir Next"/>
+              </a:rPr>
+              <a:t>: é o </a:t>
+            </a:r>
+            <a:r>
+              <a:rPr sz="1250" b="0" i="0" dirty="0" err="1">
+                <a:solidFill>
+                  <a:srgbClr val="3E4C5A"/>
+                </a:solidFill>
+                <a:latin typeface="Avenir Next"/>
+              </a:rPr>
+              <a:t>segundo</a:t>
+            </a:r>
+            <a:r>
+              <a:rPr sz="1250" b="0" i="0" dirty="0">
+                <a:solidFill>
+                  <a:srgbClr val="3E4C5A"/>
+                </a:solidFill>
+                <a:latin typeface="Avenir Next"/>
+              </a:rPr>
+              <a:t> </a:t>
+            </a:r>
+            <a:r>
+              <a:rPr sz="1250" b="0" i="0" dirty="0" err="1">
+                <a:solidFill>
+                  <a:srgbClr val="3E4C5A"/>
+                </a:solidFill>
+                <a:latin typeface="Avenir Next"/>
+              </a:rPr>
+              <a:t>sinal</a:t>
+            </a:r>
+            <a:r>
+              <a:rPr sz="1250" b="0" i="0" dirty="0">
+                <a:solidFill>
+                  <a:srgbClr val="3E4C5A"/>
+                </a:solidFill>
+                <a:latin typeface="Avenir Next"/>
+              </a:rPr>
+              <a:t> </a:t>
+            </a:r>
+            <a:r>
+              <a:rPr sz="1250" b="0" i="0" dirty="0" err="1">
+                <a:solidFill>
+                  <a:srgbClr val="3E4C5A"/>
+                </a:solidFill>
+                <a:latin typeface="Avenir Next"/>
+              </a:rPr>
+              <a:t>mais</a:t>
+            </a:r>
+            <a:r>
+              <a:rPr sz="1250" b="0" i="0" dirty="0">
+                <a:solidFill>
+                  <a:srgbClr val="3E4C5A"/>
+                </a:solidFill>
+                <a:latin typeface="Avenir Next"/>
+              </a:rPr>
+              <a:t> forte da </a:t>
+            </a:r>
+            <a:r>
+              <a:rPr sz="1250" b="0" i="0" dirty="0" err="1">
+                <a:solidFill>
+                  <a:srgbClr val="3E4C5A"/>
+                </a:solidFill>
+                <a:latin typeface="Avenir Next"/>
+              </a:rPr>
+              <a:t>lista</a:t>
+            </a:r>
+            <a:r>
+              <a:rPr sz="1250" b="0" i="0" dirty="0">
+                <a:solidFill>
+                  <a:srgbClr val="3E4C5A"/>
+                </a:solidFill>
+                <a:latin typeface="Avenir Next"/>
+              </a:rPr>
+              <a:t>.</a:t>
             </a:r>
           </a:p>
         </p:txBody>
@@ -4170,6 +5417,7 @@
           <a:lstStyle/>
           <a:p>
             <a:pPr algn="ctr"/>
+            <a:endParaRPr/>
           </a:p>
         </p:txBody>
       </p:sp>
@@ -4265,8 +5513,8 @@
         </p:nvSpPr>
         <p:spPr>
           <a:xfrm>
-            <a:off x="7223760" y="1847088"/>
-            <a:ext cx="3749040" cy="914400"/>
+            <a:off x="7018020" y="1886717"/>
+            <a:ext cx="4090219" cy="841834"/>
           </a:xfrm>
           <a:prstGeom prst="rect">
             <a:avLst/>
@@ -4288,14 +5536,112 @@
               </a:spcAft>
             </a:pPr>
             <a:r>
-              <a:rPr sz="2300" b="0" i="1">
+              <a:rPr sz="2300" b="0" i="1" dirty="0">
                 <a:solidFill>
                   <a:srgbClr val="6D8196"/>
                 </a:solidFill>
                 <a:latin typeface="Baskerville"/>
               </a:rPr>
-              <a:t>“O canal da venda
-não explica o atraso.”</a:t>
+              <a:t>“A </a:t>
+            </a:r>
+            <a:r>
+              <a:rPr sz="2300" b="0" i="1" dirty="0" err="1">
+                <a:solidFill>
+                  <a:srgbClr val="6D8196"/>
+                </a:solidFill>
+                <a:latin typeface="Baskerville"/>
+              </a:rPr>
+              <a:t>negociação</a:t>
+            </a:r>
+            <a:r>
+              <a:rPr sz="2300" b="0" i="1" dirty="0">
+                <a:solidFill>
+                  <a:srgbClr val="6D8196"/>
+                </a:solidFill>
+                <a:latin typeface="Baskerville"/>
+              </a:rPr>
+              <a:t> de </a:t>
+            </a:r>
+            <a:r>
+              <a:rPr sz="2300" b="0" i="1" dirty="0" err="1">
+                <a:solidFill>
+                  <a:srgbClr val="6D8196"/>
+                </a:solidFill>
+                <a:latin typeface="Baskerville"/>
+              </a:rPr>
+              <a:t>dívida</a:t>
+            </a:r>
+            <a:r>
+              <a:rPr sz="2300" b="0" i="1" dirty="0">
+                <a:solidFill>
+                  <a:srgbClr val="6D8196"/>
+                </a:solidFill>
+                <a:latin typeface="Baskerville"/>
+              </a:rPr>
+              <a:t> no SAC</a:t>
+            </a:r>
+            <a:r>
+              <a:rPr lang="pt-BR" sz="2300" b="0" i="1" dirty="0">
+                <a:solidFill>
+                  <a:srgbClr val="6D8196"/>
+                </a:solidFill>
+                <a:latin typeface="Baskerville"/>
+              </a:rPr>
+              <a:t> </a:t>
+            </a:r>
+            <a:r>
+              <a:rPr sz="2300" b="0" i="1" dirty="0" err="1">
+                <a:solidFill>
+                  <a:srgbClr val="6D8196"/>
+                </a:solidFill>
+                <a:latin typeface="Baskerville"/>
+              </a:rPr>
+              <a:t>chega</a:t>
+            </a:r>
+            <a:r>
+              <a:rPr sz="2300" b="0" i="1" dirty="0">
+                <a:solidFill>
+                  <a:srgbClr val="6D8196"/>
+                </a:solidFill>
+                <a:latin typeface="Baskerville"/>
+              </a:rPr>
+              <a:t> sempre </a:t>
+            </a:r>
+            <a:r>
+              <a:rPr sz="2300" b="0" i="1" dirty="0" err="1">
+                <a:solidFill>
+                  <a:srgbClr val="6D8196"/>
+                </a:solidFill>
+                <a:latin typeface="Baskerville"/>
+              </a:rPr>
+              <a:t>depois</a:t>
+            </a:r>
+            <a:r>
+              <a:rPr sz="2300" b="0" i="1" dirty="0">
+                <a:solidFill>
+                  <a:srgbClr val="6D8196"/>
+                </a:solidFill>
+                <a:latin typeface="Baskerville"/>
+              </a:rPr>
+              <a:t> do </a:t>
+            </a:r>
+            <a:r>
+              <a:rPr sz="2300" b="0" i="1" dirty="0" err="1">
+                <a:solidFill>
+                  <a:srgbClr val="6D8196"/>
+                </a:solidFill>
+                <a:latin typeface="Baskerville"/>
+              </a:rPr>
+              <a:t>atraso</a:t>
+            </a:r>
+            <a:r>
+              <a:rPr sz="2300" b="0" i="1" dirty="0">
+                <a:solidFill>
+                  <a:srgbClr val="6D8196"/>
+                </a:solidFill>
+                <a:latin typeface="Baskerville"/>
+              </a:rPr>
+              <a:t>.”</a:t>
             </a:r>
           </a:p>
         </p:txBody>
@@ -4308,7 +5654,7 @@
         </p:nvSpPr>
         <p:spPr>
           <a:xfrm>
-            <a:off x="7223760" y="2660904"/>
+            <a:off x="7188609" y="2854499"/>
             <a:ext cx="3749040" cy="310896"/>
           </a:xfrm>
           <a:prstGeom prst="rect">
@@ -4331,14 +5677,101 @@
               </a:spcAft>
             </a:pPr>
             <a:r>
-              <a:rPr sz="1050" b="0" i="0">
+              <a:rPr sz="1050" b="0" i="0" dirty="0">
                 <a:solidFill>
                   <a:srgbClr val="BFAFA4"/>
                 </a:solidFill>
                 <a:latin typeface="Avenir Next"/>
               </a:rPr>
-              <a:t>Loja, site e televendas têm o mesmo risco</a:t>
-            </a:r>
+              <a:t>707 </a:t>
+            </a:r>
+            <a:r>
+              <a:rPr sz="1050" b="0" i="0" dirty="0" err="1">
+                <a:solidFill>
+                  <a:srgbClr val="BFAFA4"/>
+                </a:solidFill>
+                <a:latin typeface="Avenir Next"/>
+              </a:rPr>
+              <a:t>ocorrências</a:t>
+            </a:r>
+            <a:r>
+              <a:rPr sz="1050" b="0" i="0" dirty="0">
+                <a:solidFill>
+                  <a:srgbClr val="BFAFA4"/>
+                </a:solidFill>
+                <a:latin typeface="Avenir Next"/>
+              </a:rPr>
+              <a:t> no </a:t>
+            </a:r>
+            <a:r>
+              <a:rPr sz="1050" b="0" i="0" dirty="0" err="1">
+                <a:solidFill>
+                  <a:srgbClr val="BFAFA4"/>
+                </a:solidFill>
+                <a:latin typeface="Avenir Next"/>
+              </a:rPr>
+              <a:t>período</a:t>
+            </a:r>
+            <a:r>
+              <a:rPr sz="1050" b="0" i="0" dirty="0">
+                <a:solidFill>
+                  <a:srgbClr val="BFAFA4"/>
+                </a:solidFill>
+                <a:latin typeface="Avenir Next"/>
+              </a:rPr>
+              <a:t> — </a:t>
+            </a:r>
+            <a:r>
+              <a:rPr sz="1050" b="0" i="0" dirty="0" err="1">
+                <a:solidFill>
+                  <a:srgbClr val="BFAFA4"/>
+                </a:solidFill>
+                <a:latin typeface="Avenir Next"/>
+              </a:rPr>
+              <a:t>nenhuma</a:t>
+            </a:r>
+            <a:r>
+              <a:rPr sz="1050" b="0" i="0" dirty="0">
+                <a:solidFill>
+                  <a:srgbClr val="BFAFA4"/>
+                </a:solidFill>
+                <a:latin typeface="Avenir Next"/>
+              </a:rPr>
+              <a:t> antes da data da </a:t>
+            </a:r>
+            <a:r>
+              <a:rPr sz="1050" b="0" i="0" dirty="0" err="1">
+                <a:solidFill>
+                  <a:srgbClr val="BFAFA4"/>
+                </a:solidFill>
+                <a:latin typeface="Avenir Next"/>
+              </a:rPr>
+              <a:t>ligação</a:t>
+            </a:r>
+            <a:r>
+              <a:rPr sz="1050" b="0" i="0" dirty="0">
+                <a:solidFill>
+                  <a:srgbClr val="BFAFA4"/>
+                </a:solidFill>
+                <a:latin typeface="Avenir Next"/>
+              </a:rPr>
+              <a:t> </a:t>
+            </a:r>
+            <a:r>
+              <a:rPr sz="1050" b="0" i="0" dirty="0" err="1">
+                <a:solidFill>
+                  <a:srgbClr val="BFAFA4"/>
+                </a:solidFill>
+                <a:latin typeface="Avenir Next"/>
+              </a:rPr>
+              <a:t>preventiva</a:t>
+            </a:r>
+            <a:endParaRPr sz="1050" b="0" i="0" dirty="0">
+              <a:solidFill>
+                <a:srgbClr val="BFAFA4"/>
+              </a:solidFill>
+              <a:latin typeface="Avenir Next"/>
+            </a:endParaRPr>
           </a:p>
         </p:txBody>
       </p:sp>
@@ -4358,7 +5791,7 @@
         </p:blipFill>
         <p:spPr>
           <a:xfrm>
-            <a:off x="7018020" y="3625989"/>
+            <a:off x="7018020" y="3692606"/>
             <a:ext cx="4160520" cy="1645134"/>
           </a:xfrm>
           <a:prstGeom prst="rect">
@@ -4375,7 +5808,7 @@
 </file>
 
 <file path=ppt/slides/slide3.xml><?xml version="1.0" encoding="utf-8"?>
-<p:sld xmlns:a="http://schemas.openxmlformats.org/drawingml/2006/main" xmlns:p="http://schemas.openxmlformats.org/presentationml/2006/main" xmlns:r="http://schemas.openxmlformats.org/officeDocument/2006/relationships">
+<p:sld xmlns:a="http://schemas.openxmlformats.org/drawingml/2006/main" xmlns:r="http://schemas.openxmlformats.org/officeDocument/2006/relationships" xmlns:p="http://schemas.openxmlformats.org/presentationml/2006/main">
   <p:cSld>
     <p:spTree>
       <p:nvGrpSpPr>
@@ -4383,7 +5816,14 @@
         <p:cNvGrpSpPr/>
         <p:nvPr/>
       </p:nvGrpSpPr>
-      <p:grpSpPr/>
+      <p:grpSpPr>
+        <a:xfrm>
+          <a:off x="0" y="0"/>
+          <a:ext cx="0" cy="0"/>
+          <a:chOff x="0" y="0"/>
+          <a:chExt cx="0" cy="0"/>
+        </a:xfrm>
+      </p:grpSpPr>
       <p:sp>
         <p:nvSpPr>
           <p:cNvPr id="2" name="Rectangle 1"/>
@@ -4425,6 +5865,7 @@
           <a:lstStyle/>
           <a:p>
             <a:pPr algn="ctr"/>
+            <a:endParaRPr/>
           </a:p>
         </p:txBody>
       </p:sp>
@@ -4472,6 +5913,7 @@
           <a:lstStyle/>
           <a:p>
             <a:pPr algn="ctr"/>
+            <a:endParaRPr/>
           </a:p>
         </p:txBody>
       </p:sp>
@@ -4516,6 +5958,7 @@
           <a:lstStyle/>
           <a:p>
             <a:pPr algn="ctr"/>
+            <a:endParaRPr/>
           </a:p>
         </p:txBody>
       </p:sp>
@@ -4663,6 +6106,7 @@
           <a:lstStyle/>
           <a:p>
             <a:pPr algn="ctr"/>
+            <a:endParaRPr/>
           </a:p>
         </p:txBody>
       </p:sp>
@@ -4674,8 +6118,8 @@
         </p:nvSpPr>
         <p:spPr>
           <a:xfrm>
-            <a:off x="841248" y="2743200"/>
-            <a:ext cx="5486400" cy="2834640"/>
+            <a:off x="841248" y="2725127"/>
+            <a:ext cx="5486400" cy="2964914"/>
           </a:xfrm>
           <a:prstGeom prst="rect">
             <a:avLst/>
@@ -4688,79 +6132,979 @@
           </a:bodyPr>
           <a:lstStyle/>
           <a:p>
-            <a:pPr algn="l">
+            <a:pPr>
               <a:lnSpc>
                 <a:spcPct val="128000"/>
               </a:lnSpc>
               <a:spcAft>
-                <a:spcPts val="1100"/>
+                <a:spcPts val="1300"/>
               </a:spcAft>
             </a:pPr>
             <a:r>
-              <a:rPr sz="1250" b="0" i="0">
-                <a:solidFill>
-                  <a:srgbClr val="3E4C5A"/>
-                </a:solidFill>
-                <a:latin typeface="Avenir Next"/>
-              </a:rPr>
-              <a:t>A fila acerta 17 contratos a mais que o critério de hoje e 28 a mais que um sorteio.</a:t>
-            </a:r>
-          </a:p>
-          <a:p>
-            <a:pPr algn="l">
+              <a:rPr sz="1350" dirty="0">
+                <a:solidFill>
+                  <a:srgbClr val="3E4C5A"/>
+                </a:solidFill>
+                <a:latin typeface="Avenir Next"/>
+              </a:rPr>
+              <a:t>A fila </a:t>
+            </a:r>
+            <a:r>
+              <a:rPr sz="1350" dirty="0" err="1">
+                <a:solidFill>
+                  <a:srgbClr val="3E4C5A"/>
+                </a:solidFill>
+                <a:latin typeface="Avenir Next"/>
+              </a:rPr>
+              <a:t>acerta</a:t>
+            </a:r>
+            <a:r>
+              <a:rPr sz="1350" dirty="0">
+                <a:solidFill>
+                  <a:srgbClr val="3E4C5A"/>
+                </a:solidFill>
+                <a:latin typeface="Avenir Next"/>
+              </a:rPr>
+              <a:t> 17 </a:t>
+            </a:r>
+            <a:r>
+              <a:rPr sz="1350" dirty="0" err="1">
+                <a:solidFill>
+                  <a:srgbClr val="3E4C5A"/>
+                </a:solidFill>
+                <a:latin typeface="Avenir Next"/>
+              </a:rPr>
+              <a:t>contratos</a:t>
+            </a:r>
+            <a:r>
+              <a:rPr sz="1350" dirty="0">
+                <a:solidFill>
+                  <a:srgbClr val="3E4C5A"/>
+                </a:solidFill>
+                <a:latin typeface="Avenir Next"/>
+              </a:rPr>
+              <a:t> a </a:t>
+            </a:r>
+            <a:r>
+              <a:rPr sz="1350" dirty="0" err="1">
+                <a:solidFill>
+                  <a:srgbClr val="3E4C5A"/>
+                </a:solidFill>
+                <a:latin typeface="Avenir Next"/>
+              </a:rPr>
+              <a:t>mais</a:t>
+            </a:r>
+            <a:r>
+              <a:rPr sz="1350" dirty="0">
+                <a:solidFill>
+                  <a:srgbClr val="3E4C5A"/>
+                </a:solidFill>
+                <a:latin typeface="Avenir Next"/>
+              </a:rPr>
+              <a:t> </a:t>
+            </a:r>
+            <a:r>
+              <a:rPr sz="1350" dirty="0" err="1">
+                <a:solidFill>
+                  <a:srgbClr val="3E4C5A"/>
+                </a:solidFill>
+                <a:latin typeface="Avenir Next"/>
+              </a:rPr>
+              <a:t>que</a:t>
+            </a:r>
+            <a:r>
+              <a:rPr sz="1350" dirty="0">
+                <a:solidFill>
+                  <a:srgbClr val="3E4C5A"/>
+                </a:solidFill>
+                <a:latin typeface="Avenir Next"/>
+              </a:rPr>
+              <a:t> o </a:t>
+            </a:r>
+            <a:r>
+              <a:rPr sz="1350" dirty="0" err="1">
+                <a:solidFill>
+                  <a:srgbClr val="3E4C5A"/>
+                </a:solidFill>
+                <a:latin typeface="Avenir Next"/>
+              </a:rPr>
+              <a:t>critério</a:t>
+            </a:r>
+            <a:r>
+              <a:rPr sz="1350" dirty="0">
+                <a:solidFill>
+                  <a:srgbClr val="3E4C5A"/>
+                </a:solidFill>
+                <a:latin typeface="Avenir Next"/>
+              </a:rPr>
+              <a:t> de </a:t>
+            </a:r>
+            <a:r>
+              <a:rPr sz="1350" dirty="0" err="1">
+                <a:solidFill>
+                  <a:srgbClr val="3E4C5A"/>
+                </a:solidFill>
+                <a:latin typeface="Avenir Next"/>
+              </a:rPr>
+              <a:t>hoje</a:t>
+            </a:r>
+            <a:r>
+              <a:rPr sz="1350" dirty="0">
+                <a:solidFill>
+                  <a:srgbClr val="3E4C5A"/>
+                </a:solidFill>
+                <a:latin typeface="Avenir Next"/>
+              </a:rPr>
+              <a:t> e 28 a </a:t>
+            </a:r>
+            <a:r>
+              <a:rPr sz="1350" dirty="0" err="1">
+                <a:solidFill>
+                  <a:srgbClr val="3E4C5A"/>
+                </a:solidFill>
+                <a:latin typeface="Avenir Next"/>
+              </a:rPr>
+              <a:t>mais</a:t>
+            </a:r>
+            <a:r>
+              <a:rPr sz="1350" dirty="0">
+                <a:solidFill>
+                  <a:srgbClr val="3E4C5A"/>
+                </a:solidFill>
+                <a:latin typeface="Avenir Next"/>
+              </a:rPr>
+              <a:t> </a:t>
+            </a:r>
+            <a:r>
+              <a:rPr sz="1350" dirty="0" err="1">
+                <a:solidFill>
+                  <a:srgbClr val="3E4C5A"/>
+                </a:solidFill>
+                <a:latin typeface="Avenir Next"/>
+              </a:rPr>
+              <a:t>que</a:t>
+            </a:r>
+            <a:r>
+              <a:rPr sz="1350" dirty="0">
+                <a:solidFill>
+                  <a:srgbClr val="3E4C5A"/>
+                </a:solidFill>
+                <a:latin typeface="Avenir Next"/>
+              </a:rPr>
+              <a:t> um </a:t>
+            </a:r>
+            <a:r>
+              <a:rPr sz="1350" dirty="0" err="1">
+                <a:solidFill>
+                  <a:srgbClr val="3E4C5A"/>
+                </a:solidFill>
+                <a:latin typeface="Avenir Next"/>
+              </a:rPr>
+              <a:t>sorteio</a:t>
+            </a:r>
+            <a:r>
+              <a:rPr sz="1350" dirty="0">
+                <a:solidFill>
+                  <a:srgbClr val="3E4C5A"/>
+                </a:solidFill>
+                <a:latin typeface="Avenir Next"/>
+              </a:rPr>
+              <a:t>.</a:t>
+            </a:r>
+          </a:p>
+          <a:p>
+            <a:pPr>
               <a:lnSpc>
                 <a:spcPct val="128000"/>
               </a:lnSpc>
               <a:spcAft>
-                <a:spcPts val="1100"/>
+                <a:spcPts val="1300"/>
               </a:spcAft>
             </a:pPr>
             <a:r>
-              <a:rPr sz="1250" b="0" i="0">
-                <a:solidFill>
-                  <a:srgbClr val="3E4C5A"/>
-                </a:solidFill>
-                <a:latin typeface="Avenir Next"/>
-              </a:rPr>
-              <a:t>As 16 ligações que sobram vão para quem pagaria de qualquer jeito e custam minutos. Os 251 contratos fora da fila custam R$ 1.200 cada, se ninguém ligar.</a:t>
-            </a:r>
-          </a:p>
-          <a:p>
-            <a:pPr algn="l">
+              <a:rPr sz="1350" dirty="0">
+                <a:solidFill>
+                  <a:srgbClr val="3E4C5A"/>
+                </a:solidFill>
+                <a:latin typeface="Avenir Next"/>
+              </a:rPr>
+              <a:t>As 16 </a:t>
+            </a:r>
+            <a:r>
+              <a:rPr sz="1350" dirty="0" err="1">
+                <a:solidFill>
+                  <a:srgbClr val="3E4C5A"/>
+                </a:solidFill>
+                <a:latin typeface="Avenir Next"/>
+              </a:rPr>
+              <a:t>ligações</a:t>
+            </a:r>
+            <a:r>
+              <a:rPr sz="1350" dirty="0">
+                <a:solidFill>
+                  <a:srgbClr val="3E4C5A"/>
+                </a:solidFill>
+                <a:latin typeface="Avenir Next"/>
+              </a:rPr>
+              <a:t> </a:t>
+            </a:r>
+            <a:r>
+              <a:rPr sz="1350" dirty="0" err="1">
+                <a:solidFill>
+                  <a:srgbClr val="3E4C5A"/>
+                </a:solidFill>
+                <a:latin typeface="Avenir Next"/>
+              </a:rPr>
+              <a:t>que</a:t>
+            </a:r>
+            <a:r>
+              <a:rPr sz="1350" dirty="0">
+                <a:solidFill>
+                  <a:srgbClr val="3E4C5A"/>
+                </a:solidFill>
+                <a:latin typeface="Avenir Next"/>
+              </a:rPr>
+              <a:t> </a:t>
+            </a:r>
+            <a:r>
+              <a:rPr sz="1350" dirty="0" err="1">
+                <a:solidFill>
+                  <a:srgbClr val="3E4C5A"/>
+                </a:solidFill>
+                <a:latin typeface="Avenir Next"/>
+              </a:rPr>
+              <a:t>sobram</a:t>
+            </a:r>
+            <a:r>
+              <a:rPr sz="1350" dirty="0">
+                <a:solidFill>
+                  <a:srgbClr val="3E4C5A"/>
+                </a:solidFill>
+                <a:latin typeface="Avenir Next"/>
+              </a:rPr>
+              <a:t> </a:t>
+            </a:r>
+            <a:r>
+              <a:rPr sz="1350" dirty="0" err="1">
+                <a:solidFill>
+                  <a:srgbClr val="3E4C5A"/>
+                </a:solidFill>
+                <a:latin typeface="Avenir Next"/>
+              </a:rPr>
+              <a:t>vão</a:t>
+            </a:r>
+            <a:r>
+              <a:rPr sz="1350" dirty="0">
+                <a:solidFill>
+                  <a:srgbClr val="3E4C5A"/>
+                </a:solidFill>
+                <a:latin typeface="Avenir Next"/>
+              </a:rPr>
+              <a:t> para quem </a:t>
+            </a:r>
+            <a:r>
+              <a:rPr sz="1350" dirty="0" err="1">
+                <a:solidFill>
+                  <a:srgbClr val="3E4C5A"/>
+                </a:solidFill>
+                <a:latin typeface="Avenir Next"/>
+              </a:rPr>
+              <a:t>pagaria</a:t>
+            </a:r>
+            <a:r>
+              <a:rPr sz="1350" dirty="0">
+                <a:solidFill>
+                  <a:srgbClr val="3E4C5A"/>
+                </a:solidFill>
+                <a:latin typeface="Avenir Next"/>
+              </a:rPr>
+              <a:t> de </a:t>
+            </a:r>
+            <a:r>
+              <a:rPr sz="1350" dirty="0" err="1">
+                <a:solidFill>
+                  <a:srgbClr val="3E4C5A"/>
+                </a:solidFill>
+                <a:latin typeface="Avenir Next"/>
+              </a:rPr>
+              <a:t>qualquer</a:t>
+            </a:r>
+            <a:r>
+              <a:rPr sz="1350" dirty="0">
+                <a:solidFill>
+                  <a:srgbClr val="3E4C5A"/>
+                </a:solidFill>
+                <a:latin typeface="Avenir Next"/>
+              </a:rPr>
+              <a:t> </a:t>
+            </a:r>
+            <a:r>
+              <a:rPr sz="1350" dirty="0" err="1">
+                <a:solidFill>
+                  <a:srgbClr val="3E4C5A"/>
+                </a:solidFill>
+                <a:latin typeface="Avenir Next"/>
+              </a:rPr>
+              <a:t>jeito</a:t>
+            </a:r>
+            <a:r>
+              <a:rPr sz="1350" dirty="0">
+                <a:solidFill>
+                  <a:srgbClr val="3E4C5A"/>
+                </a:solidFill>
+                <a:latin typeface="Avenir Next"/>
+              </a:rPr>
+              <a:t> e </a:t>
+            </a:r>
+            <a:r>
+              <a:rPr sz="1350" dirty="0" err="1">
+                <a:solidFill>
+                  <a:srgbClr val="3E4C5A"/>
+                </a:solidFill>
+                <a:latin typeface="Avenir Next"/>
+              </a:rPr>
+              <a:t>custam</a:t>
+            </a:r>
+            <a:r>
+              <a:rPr sz="1350" dirty="0">
+                <a:solidFill>
+                  <a:srgbClr val="3E4C5A"/>
+                </a:solidFill>
+                <a:latin typeface="Avenir Next"/>
+              </a:rPr>
+              <a:t> </a:t>
+            </a:r>
+            <a:r>
+              <a:rPr sz="1350" dirty="0" err="1">
+                <a:solidFill>
+                  <a:srgbClr val="3E4C5A"/>
+                </a:solidFill>
+                <a:latin typeface="Avenir Next"/>
+              </a:rPr>
+              <a:t>minutos</a:t>
+            </a:r>
+            <a:r>
+              <a:rPr sz="1350" dirty="0">
+                <a:solidFill>
+                  <a:srgbClr val="3E4C5A"/>
+                </a:solidFill>
+                <a:latin typeface="Avenir Next"/>
+              </a:rPr>
+              <a:t>. </a:t>
+            </a:r>
+            <a:r>
+              <a:rPr sz="1350" dirty="0" err="1">
+                <a:solidFill>
+                  <a:srgbClr val="3E4C5A"/>
+                </a:solidFill>
+                <a:latin typeface="Avenir Next"/>
+              </a:rPr>
+              <a:t>Os</a:t>
+            </a:r>
+            <a:r>
+              <a:rPr sz="1350" dirty="0">
+                <a:solidFill>
+                  <a:srgbClr val="3E4C5A"/>
+                </a:solidFill>
+                <a:latin typeface="Avenir Next"/>
+              </a:rPr>
+              <a:t> 251 </a:t>
+            </a:r>
+            <a:r>
+              <a:rPr sz="1350" dirty="0" err="1">
+                <a:solidFill>
+                  <a:srgbClr val="3E4C5A"/>
+                </a:solidFill>
+                <a:latin typeface="Avenir Next"/>
+              </a:rPr>
+              <a:t>contratos</a:t>
+            </a:r>
+            <a:r>
+              <a:rPr sz="1350" dirty="0">
+                <a:solidFill>
+                  <a:srgbClr val="3E4C5A"/>
+                </a:solidFill>
+                <a:latin typeface="Avenir Next"/>
+              </a:rPr>
+              <a:t> fora da fila </a:t>
+            </a:r>
+            <a:r>
+              <a:rPr sz="1350" dirty="0" err="1">
+                <a:solidFill>
+                  <a:srgbClr val="3E4C5A"/>
+                </a:solidFill>
+                <a:latin typeface="Avenir Next"/>
+              </a:rPr>
+              <a:t>custam</a:t>
+            </a:r>
+            <a:r>
+              <a:rPr sz="1350" dirty="0">
+                <a:solidFill>
+                  <a:srgbClr val="3E4C5A"/>
+                </a:solidFill>
+                <a:latin typeface="Avenir Next"/>
+              </a:rPr>
+              <a:t> R$ 1.200 </a:t>
+            </a:r>
+            <a:r>
+              <a:rPr sz="1350" dirty="0" err="1">
+                <a:solidFill>
+                  <a:srgbClr val="3E4C5A"/>
+                </a:solidFill>
+                <a:latin typeface="Avenir Next"/>
+              </a:rPr>
+              <a:t>cada</a:t>
+            </a:r>
+            <a:r>
+              <a:rPr sz="1350" dirty="0">
+                <a:solidFill>
+                  <a:srgbClr val="3E4C5A"/>
+                </a:solidFill>
+                <a:latin typeface="Avenir Next"/>
+              </a:rPr>
+              <a:t>, se </a:t>
+            </a:r>
+            <a:r>
+              <a:rPr sz="1350" dirty="0" err="1">
+                <a:solidFill>
+                  <a:srgbClr val="3E4C5A"/>
+                </a:solidFill>
+                <a:latin typeface="Avenir Next"/>
+              </a:rPr>
+              <a:t>ninguém</a:t>
+            </a:r>
+            <a:r>
+              <a:rPr sz="1350" dirty="0">
+                <a:solidFill>
+                  <a:srgbClr val="3E4C5A"/>
+                </a:solidFill>
+                <a:latin typeface="Avenir Next"/>
+              </a:rPr>
+              <a:t> </a:t>
+            </a:r>
+            <a:r>
+              <a:rPr sz="1350" dirty="0" err="1">
+                <a:solidFill>
+                  <a:srgbClr val="3E4C5A"/>
+                </a:solidFill>
+                <a:latin typeface="Avenir Next"/>
+              </a:rPr>
+              <a:t>ligar</a:t>
+            </a:r>
+            <a:r>
+              <a:rPr sz="1350" dirty="0">
+                <a:solidFill>
+                  <a:srgbClr val="3E4C5A"/>
+                </a:solidFill>
+                <a:latin typeface="Avenir Next"/>
+              </a:rPr>
+              <a:t>.</a:t>
+            </a:r>
+          </a:p>
+          <a:p>
+            <a:pPr>
               <a:lnSpc>
                 <a:spcPct val="128000"/>
               </a:lnSpc>
               <a:spcAft>
-                <a:spcPts val="1100"/>
+                <a:spcPts val="1300"/>
               </a:spcAft>
             </a:pPr>
             <a:r>
-              <a:rPr sz="1250" b="0" i="0">
-                <a:solidFill>
-                  <a:srgbClr val="3E4C5A"/>
-                </a:solidFill>
-                <a:latin typeface="Avenir Next"/>
-              </a:rPr>
-              <a:t>O limite não é o modelo, é a agenda: com 315 contratos em risco e 80 ligações, alcançamos no máximo 25% deles.</a:t>
-            </a:r>
-          </a:p>
-          <a:p>
-            <a:pPr algn="l">
+              <a:rPr sz="1350" dirty="0">
+                <a:solidFill>
+                  <a:srgbClr val="3E4C5A"/>
+                </a:solidFill>
+                <a:latin typeface="Avenir Next"/>
+              </a:rPr>
+              <a:t>O </a:t>
+            </a:r>
+            <a:r>
+              <a:rPr sz="1350" dirty="0" err="1">
+                <a:solidFill>
+                  <a:srgbClr val="3E4C5A"/>
+                </a:solidFill>
+                <a:latin typeface="Avenir Next"/>
+              </a:rPr>
+              <a:t>limite</a:t>
+            </a:r>
+            <a:r>
+              <a:rPr sz="1350" dirty="0">
+                <a:solidFill>
+                  <a:srgbClr val="3E4C5A"/>
+                </a:solidFill>
+                <a:latin typeface="Avenir Next"/>
+              </a:rPr>
+              <a:t> </a:t>
+            </a:r>
+            <a:r>
+              <a:rPr sz="1350" dirty="0" err="1">
+                <a:solidFill>
+                  <a:srgbClr val="3E4C5A"/>
+                </a:solidFill>
+                <a:latin typeface="Avenir Next"/>
+              </a:rPr>
+              <a:t>não</a:t>
+            </a:r>
+            <a:r>
+              <a:rPr sz="1350" dirty="0">
+                <a:solidFill>
+                  <a:srgbClr val="3E4C5A"/>
+                </a:solidFill>
+                <a:latin typeface="Avenir Next"/>
+              </a:rPr>
+              <a:t> é o </a:t>
+            </a:r>
+            <a:r>
+              <a:rPr sz="1350" dirty="0" err="1">
+                <a:solidFill>
+                  <a:srgbClr val="3E4C5A"/>
+                </a:solidFill>
+                <a:latin typeface="Avenir Next"/>
+              </a:rPr>
+              <a:t>modelo</a:t>
+            </a:r>
+            <a:r>
+              <a:rPr sz="1350" dirty="0">
+                <a:solidFill>
+                  <a:srgbClr val="3E4C5A"/>
+                </a:solidFill>
+                <a:latin typeface="Avenir Next"/>
+              </a:rPr>
+              <a:t>, é a agenda: </a:t>
+            </a:r>
+            <a:r>
+              <a:rPr sz="1350" dirty="0" err="1">
+                <a:solidFill>
+                  <a:srgbClr val="3E4C5A"/>
+                </a:solidFill>
+                <a:latin typeface="Avenir Next"/>
+              </a:rPr>
+              <a:t>na</a:t>
+            </a:r>
+            <a:r>
+              <a:rPr sz="1350" dirty="0">
+                <a:solidFill>
+                  <a:srgbClr val="3E4C5A"/>
+                </a:solidFill>
+                <a:latin typeface="Avenir Next"/>
+              </a:rPr>
+              <a:t> </a:t>
+            </a:r>
+            <a:r>
+              <a:rPr sz="1350" dirty="0" err="1">
+                <a:solidFill>
+                  <a:srgbClr val="3E4C5A"/>
+                </a:solidFill>
+                <a:latin typeface="Avenir Next"/>
+              </a:rPr>
+              <a:t>janela</a:t>
+            </a:r>
+            <a:r>
+              <a:rPr sz="1350" dirty="0">
+                <a:solidFill>
+                  <a:srgbClr val="3E4C5A"/>
+                </a:solidFill>
+                <a:latin typeface="Avenir Next"/>
+              </a:rPr>
+              <a:t> de teste (315 </a:t>
+            </a:r>
+            <a:r>
+              <a:rPr sz="1350" dirty="0" err="1">
+                <a:solidFill>
+                  <a:srgbClr val="3E4C5A"/>
+                </a:solidFill>
+                <a:latin typeface="Avenir Next"/>
+              </a:rPr>
+              <a:t>inadimplentes</a:t>
+            </a:r>
+            <a:r>
+              <a:rPr sz="1350" dirty="0">
+                <a:solidFill>
+                  <a:srgbClr val="3E4C5A"/>
+                </a:solidFill>
+                <a:latin typeface="Avenir Next"/>
+              </a:rPr>
+              <a:t>, 11 </a:t>
+            </a:r>
+            <a:r>
+              <a:rPr sz="1350" dirty="0" err="1">
+                <a:solidFill>
+                  <a:srgbClr val="3E4C5A"/>
+                </a:solidFill>
+                <a:latin typeface="Avenir Next"/>
+              </a:rPr>
+              <a:t>dias</a:t>
+            </a:r>
+            <a:r>
+              <a:rPr sz="1350" dirty="0">
+                <a:solidFill>
+                  <a:srgbClr val="3E4C5A"/>
+                </a:solidFill>
+                <a:latin typeface="Avenir Next"/>
+              </a:rPr>
+              <a:t>), 80 </a:t>
+            </a:r>
+            <a:r>
+              <a:rPr sz="1350" dirty="0" err="1">
+                <a:solidFill>
+                  <a:srgbClr val="3E4C5A"/>
+                </a:solidFill>
+                <a:latin typeface="Avenir Next"/>
+              </a:rPr>
+              <a:t>ligações</a:t>
+            </a:r>
+            <a:r>
+              <a:rPr sz="1350" dirty="0">
+                <a:solidFill>
+                  <a:srgbClr val="3E4C5A"/>
+                </a:solidFill>
+                <a:latin typeface="Avenir Next"/>
+              </a:rPr>
+              <a:t> </a:t>
+            </a:r>
+            <a:r>
+              <a:rPr sz="1350" dirty="0" err="1">
+                <a:solidFill>
+                  <a:srgbClr val="3E4C5A"/>
+                </a:solidFill>
+                <a:latin typeface="Avenir Next"/>
+              </a:rPr>
+              <a:t>capturam</a:t>
+            </a:r>
+            <a:r>
+              <a:rPr sz="1350" dirty="0">
+                <a:solidFill>
+                  <a:srgbClr val="3E4C5A"/>
+                </a:solidFill>
+                <a:latin typeface="Avenir Next"/>
+              </a:rPr>
+              <a:t> 20% — o </a:t>
+            </a:r>
+            <a:r>
+              <a:rPr sz="1350" dirty="0" err="1">
+                <a:solidFill>
+                  <a:srgbClr val="3E4C5A"/>
+                </a:solidFill>
+                <a:latin typeface="Avenir Next"/>
+              </a:rPr>
+              <a:t>teto</a:t>
+            </a:r>
+            <a:r>
+              <a:rPr sz="1350" dirty="0">
+                <a:solidFill>
+                  <a:srgbClr val="3E4C5A"/>
+                </a:solidFill>
+                <a:latin typeface="Avenir Next"/>
+              </a:rPr>
+              <a:t> </a:t>
+            </a:r>
+            <a:r>
+              <a:rPr sz="1350" dirty="0" err="1">
+                <a:solidFill>
+                  <a:srgbClr val="3E4C5A"/>
+                </a:solidFill>
+                <a:latin typeface="Avenir Next"/>
+              </a:rPr>
+              <a:t>teórico</a:t>
+            </a:r>
+            <a:r>
+              <a:rPr sz="1350" dirty="0">
+                <a:solidFill>
+                  <a:srgbClr val="3E4C5A"/>
+                </a:solidFill>
+                <a:latin typeface="Avenir Next"/>
+              </a:rPr>
+              <a:t> é 25%.</a:t>
+            </a:r>
+          </a:p>
+          <a:p>
+            <a:pPr>
               <a:lnSpc>
                 <a:spcPct val="128000"/>
               </a:lnSpc>
               <a:spcAft>
-                <a:spcPts val="1100"/>
+                <a:spcPts val="1300"/>
               </a:spcAft>
             </a:pPr>
             <a:r>
-              <a:rPr sz="1250" b="0" i="0">
-                <a:solidFill>
-                  <a:srgbClr val="3E4C5A"/>
-                </a:solidFill>
-                <a:latin typeface="Avenir Next"/>
-              </a:rPr>
-              <a:t>Para melhorar: medir quantos renegociam após a ligação, dado que ainda não existe, e testar mais ligações por semana.</a:t>
+              <a:rPr sz="1350" dirty="0">
+                <a:solidFill>
+                  <a:srgbClr val="3E4C5A"/>
+                </a:solidFill>
+                <a:latin typeface="Avenir Next"/>
+              </a:rPr>
+              <a:t>Para </a:t>
+            </a:r>
+            <a:r>
+              <a:rPr sz="1350" dirty="0" err="1">
+                <a:solidFill>
+                  <a:srgbClr val="3E4C5A"/>
+                </a:solidFill>
+                <a:latin typeface="Avenir Next"/>
+              </a:rPr>
+              <a:t>melhorar</a:t>
+            </a:r>
+            <a:r>
+              <a:rPr sz="1350" dirty="0">
+                <a:solidFill>
+                  <a:srgbClr val="3E4C5A"/>
+                </a:solidFill>
+                <a:latin typeface="Avenir Next"/>
+              </a:rPr>
+              <a:t>: </a:t>
+            </a:r>
+            <a:r>
+              <a:rPr sz="1350" dirty="0" err="1">
+                <a:solidFill>
+                  <a:srgbClr val="3E4C5A"/>
+                </a:solidFill>
+                <a:latin typeface="Avenir Next"/>
+              </a:rPr>
+              <a:t>medir</a:t>
+            </a:r>
+            <a:r>
+              <a:rPr sz="1350" dirty="0">
+                <a:solidFill>
+                  <a:srgbClr val="3E4C5A"/>
+                </a:solidFill>
+                <a:latin typeface="Avenir Next"/>
+              </a:rPr>
+              <a:t> </a:t>
+            </a:r>
+            <a:r>
+              <a:rPr sz="1350" dirty="0" err="1">
+                <a:solidFill>
+                  <a:srgbClr val="3E4C5A"/>
+                </a:solidFill>
+                <a:latin typeface="Avenir Next"/>
+              </a:rPr>
+              <a:t>quantos</a:t>
+            </a:r>
+            <a:r>
+              <a:rPr sz="1350" dirty="0">
+                <a:solidFill>
+                  <a:srgbClr val="3E4C5A"/>
+                </a:solidFill>
+                <a:latin typeface="Avenir Next"/>
+              </a:rPr>
+              <a:t> </a:t>
+            </a:r>
+            <a:r>
+              <a:rPr sz="1350" dirty="0" err="1">
+                <a:solidFill>
+                  <a:srgbClr val="3E4C5A"/>
+                </a:solidFill>
+                <a:latin typeface="Avenir Next"/>
+              </a:rPr>
+              <a:t>renegociam</a:t>
+            </a:r>
+            <a:r>
+              <a:rPr sz="1350" dirty="0">
+                <a:solidFill>
+                  <a:srgbClr val="3E4C5A"/>
+                </a:solidFill>
+                <a:latin typeface="Avenir Next"/>
+              </a:rPr>
+              <a:t> </a:t>
+            </a:r>
+            <a:r>
+              <a:rPr sz="1350" dirty="0" err="1">
+                <a:solidFill>
+                  <a:srgbClr val="3E4C5A"/>
+                </a:solidFill>
+                <a:latin typeface="Avenir Next"/>
+              </a:rPr>
+              <a:t>após</a:t>
+            </a:r>
+            <a:r>
+              <a:rPr sz="1350" dirty="0">
+                <a:solidFill>
+                  <a:srgbClr val="3E4C5A"/>
+                </a:solidFill>
+                <a:latin typeface="Avenir Next"/>
+              </a:rPr>
+              <a:t> a </a:t>
+            </a:r>
+            <a:r>
+              <a:rPr sz="1350" dirty="0" err="1">
+                <a:solidFill>
+                  <a:srgbClr val="3E4C5A"/>
+                </a:solidFill>
+                <a:latin typeface="Avenir Next"/>
+              </a:rPr>
+              <a:t>ligação</a:t>
+            </a:r>
+            <a:r>
+              <a:rPr sz="1350" dirty="0">
+                <a:solidFill>
+                  <a:srgbClr val="3E4C5A"/>
+                </a:solidFill>
+                <a:latin typeface="Avenir Next"/>
+              </a:rPr>
+              <a:t>, dado </a:t>
+            </a:r>
+            <a:r>
+              <a:rPr sz="1350" dirty="0" err="1">
+                <a:solidFill>
+                  <a:srgbClr val="3E4C5A"/>
+                </a:solidFill>
+                <a:latin typeface="Avenir Next"/>
+              </a:rPr>
+              <a:t>que</a:t>
+            </a:r>
+            <a:r>
+              <a:rPr sz="1350" dirty="0">
+                <a:solidFill>
+                  <a:srgbClr val="3E4C5A"/>
+                </a:solidFill>
+                <a:latin typeface="Avenir Next"/>
+              </a:rPr>
+              <a:t> </a:t>
+            </a:r>
+            <a:r>
+              <a:rPr sz="1350" dirty="0" err="1">
+                <a:solidFill>
+                  <a:srgbClr val="3E4C5A"/>
+                </a:solidFill>
+                <a:latin typeface="Avenir Next"/>
+              </a:rPr>
+              <a:t>ainda</a:t>
+            </a:r>
+            <a:r>
+              <a:rPr sz="1350" dirty="0">
+                <a:solidFill>
+                  <a:srgbClr val="3E4C5A"/>
+                </a:solidFill>
+                <a:latin typeface="Avenir Next"/>
+              </a:rPr>
+              <a:t> </a:t>
+            </a:r>
+            <a:r>
+              <a:rPr sz="1350" dirty="0" err="1">
+                <a:solidFill>
+                  <a:srgbClr val="3E4C5A"/>
+                </a:solidFill>
+                <a:latin typeface="Avenir Next"/>
+              </a:rPr>
+              <a:t>não</a:t>
+            </a:r>
+            <a:r>
+              <a:rPr sz="1350" dirty="0">
+                <a:solidFill>
+                  <a:srgbClr val="3E4C5A"/>
+                </a:solidFill>
+                <a:latin typeface="Avenir Next"/>
+              </a:rPr>
+              <a:t> </a:t>
+            </a:r>
+            <a:r>
+              <a:rPr sz="1350" dirty="0" err="1">
+                <a:solidFill>
+                  <a:srgbClr val="3E4C5A"/>
+                </a:solidFill>
+                <a:latin typeface="Avenir Next"/>
+              </a:rPr>
+              <a:t>existe</a:t>
+            </a:r>
+            <a:r>
+              <a:rPr sz="1350" dirty="0">
+                <a:solidFill>
+                  <a:srgbClr val="3E4C5A"/>
+                </a:solidFill>
+                <a:latin typeface="Avenir Next"/>
+              </a:rPr>
+              <a:t>, e </a:t>
+            </a:r>
+            <a:r>
+              <a:rPr sz="1350" dirty="0" err="1">
+                <a:solidFill>
+                  <a:srgbClr val="3E4C5A"/>
+                </a:solidFill>
+                <a:latin typeface="Avenir Next"/>
+              </a:rPr>
+              <a:t>testar</a:t>
+            </a:r>
+            <a:r>
+              <a:rPr sz="1350" dirty="0">
+                <a:solidFill>
+                  <a:srgbClr val="3E4C5A"/>
+                </a:solidFill>
+                <a:latin typeface="Avenir Next"/>
+              </a:rPr>
+              <a:t> </a:t>
+            </a:r>
+            <a:r>
+              <a:rPr sz="1350" dirty="0" err="1">
+                <a:solidFill>
+                  <a:srgbClr val="3E4C5A"/>
+                </a:solidFill>
+                <a:latin typeface="Avenir Next"/>
+              </a:rPr>
+              <a:t>mais</a:t>
+            </a:r>
+            <a:r>
+              <a:rPr sz="1350" dirty="0">
+                <a:solidFill>
+                  <a:srgbClr val="3E4C5A"/>
+                </a:solidFill>
+                <a:latin typeface="Avenir Next"/>
+              </a:rPr>
+              <a:t> </a:t>
+            </a:r>
+            <a:r>
+              <a:rPr sz="1350" dirty="0" err="1">
+                <a:solidFill>
+                  <a:srgbClr val="3E4C5A"/>
+                </a:solidFill>
+                <a:latin typeface="Avenir Next"/>
+              </a:rPr>
+              <a:t>ligações</a:t>
+            </a:r>
+            <a:r>
+              <a:rPr sz="1350" dirty="0">
+                <a:solidFill>
+                  <a:srgbClr val="3E4C5A"/>
+                </a:solidFill>
+                <a:latin typeface="Avenir Next"/>
+              </a:rPr>
+              <a:t> </a:t>
+            </a:r>
+            <a:r>
+              <a:rPr sz="1350" dirty="0" err="1">
+                <a:solidFill>
+                  <a:srgbClr val="3E4C5A"/>
+                </a:solidFill>
+                <a:latin typeface="Avenir Next"/>
+              </a:rPr>
+              <a:t>por</a:t>
+            </a:r>
+            <a:r>
+              <a:rPr sz="1350" dirty="0">
+                <a:solidFill>
+                  <a:srgbClr val="3E4C5A"/>
+                </a:solidFill>
+                <a:latin typeface="Avenir Next"/>
+              </a:rPr>
+              <a:t> </a:t>
+            </a:r>
+            <a:r>
+              <a:rPr sz="1350" dirty="0" err="1">
+                <a:solidFill>
+                  <a:srgbClr val="3E4C5A"/>
+                </a:solidFill>
+                <a:latin typeface="Avenir Next"/>
+              </a:rPr>
+              <a:t>semana</a:t>
+            </a:r>
+            <a:r>
+              <a:rPr sz="1350" dirty="0">
+                <a:solidFill>
+                  <a:srgbClr val="3E4C5A"/>
+                </a:solidFill>
+                <a:latin typeface="Avenir Next"/>
+              </a:rPr>
+              <a:t>.</a:t>
             </a:r>
           </a:p>
         </p:txBody>
@@ -4806,6 +7150,7 @@
           <a:lstStyle/>
           <a:p>
             <a:pPr algn="ctr"/>
+            <a:endParaRPr/>
           </a:p>
         </p:txBody>
       </p:sp>

</xml_diff>